<commit_message>
Deploy Lotlight on Firebase with verified accounts and narrated demo
</commit_message>
<xml_diff>
--- a/submission/Lotlight-Pitch.pptx
+++ b/submission/Lotlight-Pitch.pptx
@@ -2,19 +2,19 @@
 <file path=ppt/presentation.xml><?xml version="1.0" encoding="utf-8"?>
 <p:presentation xmlns:p="http://schemas.openxmlformats.org/presentationml/2006/main">
   <p:sldMasterIdLst>
-    <p:sldMasterId xmlns:r="http://schemas.openxmlformats.org/officeDocument/2006/relationships" id="2147483648" r:id="R162f1dd803e540ce"/>
+    <p:sldMasterId xmlns:r="http://schemas.openxmlformats.org/officeDocument/2006/relationships" id="2147483648" r:id="R0a59fc1ea4dc4e1b"/>
   </p:sldMasterIdLst>
   <p:notesMasterIdLst>
-    <p:notesMasterId xmlns:r="http://schemas.openxmlformats.org/officeDocument/2006/relationships" r:id="R35eca59b87274664"/>
+    <p:notesMasterId xmlns:r="http://schemas.openxmlformats.org/officeDocument/2006/relationships" r:id="R9b060e064da4416b"/>
   </p:notesMasterIdLst>
   <p:sldIdLst>
-    <p:sldId xmlns:r="http://schemas.openxmlformats.org/officeDocument/2006/relationships" id="256" r:id="R27c71ea19b194609"/>
-    <p:sldId xmlns:r="http://schemas.openxmlformats.org/officeDocument/2006/relationships" id="257" r:id="R214909476e2d4bea"/>
-    <p:sldId xmlns:r="http://schemas.openxmlformats.org/officeDocument/2006/relationships" id="258" r:id="R8bff9425bf7a4546"/>
-    <p:sldId xmlns:r="http://schemas.openxmlformats.org/officeDocument/2006/relationships" id="259" r:id="Rf8fac6bb97b0487c"/>
-    <p:sldId xmlns:r="http://schemas.openxmlformats.org/officeDocument/2006/relationships" id="260" r:id="R34e64bf92595495b"/>
-    <p:sldId xmlns:r="http://schemas.openxmlformats.org/officeDocument/2006/relationships" id="261" r:id="R08e27c66862a4021"/>
-    <p:sldId xmlns:r="http://schemas.openxmlformats.org/officeDocument/2006/relationships" id="262" r:id="Rb2471e38a01c400f"/>
+    <p:sldId xmlns:r="http://schemas.openxmlformats.org/officeDocument/2006/relationships" id="256" r:id="R7b430f64ca214ab1"/>
+    <p:sldId xmlns:r="http://schemas.openxmlformats.org/officeDocument/2006/relationships" id="257" r:id="R89a7ea3d8dc94a5c"/>
+    <p:sldId xmlns:r="http://schemas.openxmlformats.org/officeDocument/2006/relationships" id="258" r:id="R4d26547b528b4664"/>
+    <p:sldId xmlns:r="http://schemas.openxmlformats.org/officeDocument/2006/relationships" id="259" r:id="R7eb18993fa66412e"/>
+    <p:sldId xmlns:r="http://schemas.openxmlformats.org/officeDocument/2006/relationships" id="260" r:id="R9d0308dfff0444ff"/>
+    <p:sldId xmlns:r="http://schemas.openxmlformats.org/officeDocument/2006/relationships" id="261" r:id="Ra3a6f11b375b4210"/>
+    <p:sldId xmlns:r="http://schemas.openxmlformats.org/officeDocument/2006/relationships" id="262" r:id="R85ef224d1d564a5f"/>
   </p:sldIdLst>
   <p:sldSz cx="12192000" cy="6858000"/>
   <p:notesSz cx="6858000" cy="9144000"/>
@@ -698,7 +698,7 @@
           <a:lstStyle xmlns:a="http://schemas.openxmlformats.org/drawingml/2006/main"/>
           <a:p xmlns:a="http://schemas.openxmlformats.org/drawingml/2006/main">
             <a:r>
-              <a:t>Here is the demo path. First, load the sample or bring a stock CSV and the text of a notice. Text-based PDF and TXT imports are supported, but the parser intentionally accepts supported labeled lines. Staff must transcribe PDF tables into labeled catalog and lot lines and check them against the original. Next, review exact pair evidence and unresolved identifiers, then approve the source scope. Record a staff response with the responsible person, a full quantity and evidence. Finally, sign in to save the workspace and export the audit. Immutable source and inventory snapshots preserve the basis of each response. A correction to one inventory line retains other actions. This MVP does not offer shared team roles, live inventory integrations or automatic recall monitoring.</a:t>
+              <a:t>Here is the demo path. First, load the sample or bring a stock CSV and the text of a notice. Text-based PDF and TXT imports are supported, but the parser intentionally accepts supported labeled lines. Staff must transcribe PDF tables into labeled catalog and lot lines and check them against the original. Next, review exact pair evidence and unresolved identifiers, then approve the source scope. Record a staff response with the responsible person, a full quantity and evidence. Finally, sign in with Firebase Authentication to save the workspace and export the audit. Firebase Hosting serves the public app, Cloud Run serves the API, and Firestore stores the account workspace. Immutable source and inventory snapshots preserve the basis of each response. A correction to one inventory line retains other actions. This MVP does not offer shared team roles, live inventory integrations or automatic recall monitoring.</a:t>
             </a:r>
           </a:p>
           <a:p xmlns:a="http://schemas.openxmlformats.org/drawingml/2006/main">
@@ -863,7 +863,7 @@
           <a:lstStyle xmlns:a="http://schemas.openxmlformats.org/drawingml/2006/main"/>
           <a:p xmlns:a="http://schemas.openxmlformats.org/drawingml/2006/main">
             <a:r>
-              <a:t>Thirty-three automated logic checks pass. Completed browser checks cover the review workflow, sign-in and persistence, exports and mobile use. We also ran real local AI inference on twelve hand-authored synthetic descriptions, with six relevant examples. The top six semantic results contained five of the relevant examples. Lexical matching found four. With a threshold of 0.3 chosen after inspecting this tiny set, the system surfaced five relevant candidates and no negative examples. It still missed one plausible alias. This is a smoke test and demonstration, not a held-out benchmark or a statistical accuracy claim. There are no real users or clinical validation yet. The next step is a supervised drill with clinic staff.</a:t>
+              <a:t>Thirty-six automated unit tests pass. Ten public Firebase browser tests pass, covering the review workflow, sign-in and persistence, exports and mobile use. We also ran real local AI inference on twelve hand-authored synthetic descriptions, with six relevant examples. The top six semantic results contained five of the relevant examples. Lexical matching found four. With a threshold of 0.3 chosen after inspecting this tiny set, the system surfaced five relevant candidates and no negative examples. It still missed one plausible alias. This is a smoke test and demonstration, not a held-out benchmark or a statistical accuracy claim. There are no real users or clinical validation yet. The next step is a supervised drill with clinic staff.</a:t>
             </a:r>
           </a:p>
           <a:p xmlns:a="http://schemas.openxmlformats.org/drawingml/2006/main">
@@ -943,7 +943,7 @@
           <a:lstStyle xmlns:a="http://schemas.openxmlformats.org/drawingml/2006/main"/>
           <a:p xmlns:a="http://schemas.openxmlformats.org/drawingml/2006/main">
             <a:r>
-              <a:t>Lotlight is ready for its next honest test: a supervised recall drill with clinic staff. I want to recruit three pilot clinics, compare review time and missed identifiers with their existing process, and learn whether the evidence record is useful enough to pay for. The goal is simple: help a small healthcare team turn a notice into a documented response. I’m Shivam Gupta. Thank you.</a:t>
+              <a:t>Lotlight is ready for its next honest test: a supervised recall drill with clinic staff. I want to recruit three pilot clinics, compare review time and missed identifiers with their existing process, and learn whether the evidence record is useful enough to pay for. The goal is simple: help a small healthcare team turn a notice into a documented response. Try the public app at https://lotlight-care.web.app. The submission includes a 169-second AI-narrated demonstration with captions. I’m Shivam Gupta. Thank you.</a:t>
             </a:r>
           </a:p>
           <a:p xmlns:a="http://schemas.openxmlformats.org/drawingml/2006/main">
@@ -1021,7 +1021,7 @@
   </p:cSld>
   <p:clrMap bg1="lt1" tx1="dk1" bg2="lt2" tx2="dk2" accent1="accent1" accent2="accent2" accent3="accent3" accent4="accent4" accent5="accent5" accent6="accent6" hlink="hlink" folHlink="folHlink"/>
   <p:sldLayoutIdLst>
-    <p:sldLayoutId xmlns:r="http://schemas.openxmlformats.org/officeDocument/2006/relationships" id="2147483649" r:id="R298db0773444438e"/>
+    <p:sldLayoutId xmlns:r="http://schemas.openxmlformats.org/officeDocument/2006/relationships" id="2147483649" r:id="R9c3ac9a9e885448b"/>
   </p:sldLayoutIdLst>
   <p:txStyles>
     <p:titleStyle>
@@ -1572,7 +1572,7 @@
           <p:cNvPr id="9" name="">
             <a:extLst xmlns:a="http://schemas.openxmlformats.org/drawingml/2006/main">
               <a:ext uri="{FF2B5EF4-FFF2-40B4-BE49-F238E27FC236}">
-                <a16:creationId xmlns:a16="http://schemas.microsoft.com/office/drawing/2014/main" id="{436F83F8-42A8-4F43-93CE-81423BCACD41}"/>
+                <a16:creationId xmlns:a16="http://schemas.microsoft.com/office/drawing/2014/main" id="{EC9A1FFD-47C0-4E34-9648-5E2FAC10F018}"/>
               </a:ext>
             </a:extLst>
           </p:cNvPr>
@@ -1629,7 +1629,7 @@
           <p:cNvPr id="2" name="">
             <a:extLst xmlns:a="http://schemas.openxmlformats.org/drawingml/2006/main">
               <a:ext uri="{FF2B5EF4-FFF2-40B4-BE49-F238E27FC236}">
-                <a16:creationId xmlns:a16="http://schemas.microsoft.com/office/drawing/2014/main" id="{9005A8E3-59DD-4E01-9B7A-737F0D9C1FCF}"/>
+                <a16:creationId xmlns:a16="http://schemas.microsoft.com/office/drawing/2014/main" id="{B6C3B23E-A577-4B3B-8CFD-8AD46EDD809A}"/>
               </a:ext>
             </a:extLst>
           </p:cNvPr>
@@ -1686,7 +1686,7 @@
           <p:cNvPr id="3" name="">
             <a:extLst xmlns:a="http://schemas.openxmlformats.org/drawingml/2006/main">
               <a:ext uri="{FF2B5EF4-FFF2-40B4-BE49-F238E27FC236}">
-                <a16:creationId xmlns:a16="http://schemas.microsoft.com/office/drawing/2014/main" id="{727D7674-3CB5-4262-8F24-E5C589FCFD2E}"/>
+                <a16:creationId xmlns:a16="http://schemas.microsoft.com/office/drawing/2014/main" id="{56D5B81A-72DB-4E56-8435-425A926AF484}"/>
               </a:ext>
             </a:extLst>
           </p:cNvPr>
@@ -1766,7 +1766,7 @@
           <p:cNvPr id="4" name="">
             <a:extLst xmlns:a="http://schemas.openxmlformats.org/drawingml/2006/main">
               <a:ext uri="{FF2B5EF4-FFF2-40B4-BE49-F238E27FC236}">
-                <a16:creationId xmlns:a16="http://schemas.microsoft.com/office/drawing/2014/main" id="{D7CA5656-491B-40D6-A272-133E22984DD5}"/>
+                <a16:creationId xmlns:a16="http://schemas.microsoft.com/office/drawing/2014/main" id="{F0098A41-0605-45CC-B31B-6B377D08A753}"/>
               </a:ext>
             </a:extLst>
           </p:cNvPr>
@@ -1823,7 +1823,7 @@
           <p:cNvPr id="5" name="">
             <a:extLst xmlns:a="http://schemas.openxmlformats.org/drawingml/2006/main">
               <a:ext uri="{FF2B5EF4-FFF2-40B4-BE49-F238E27FC236}">
-                <a16:creationId xmlns:a16="http://schemas.microsoft.com/office/drawing/2014/main" id="{181DA759-82D1-41D2-B6EA-3EEA90B03856}"/>
+                <a16:creationId xmlns:a16="http://schemas.microsoft.com/office/drawing/2014/main" id="{7F0101D1-F4E2-47CE-AB59-69A4A98EB2F3}"/>
               </a:ext>
             </a:extLst>
           </p:cNvPr>
@@ -1880,7 +1880,7 @@
           <p:cNvPr id="6" name="">
             <a:extLst xmlns:a="http://schemas.openxmlformats.org/drawingml/2006/main">
               <a:ext uri="{FF2B5EF4-FFF2-40B4-BE49-F238E27FC236}">
-                <a16:creationId xmlns:a16="http://schemas.microsoft.com/office/drawing/2014/main" id="{F1A1B08F-0AD1-4B0B-BCD5-36E2B8C20032}"/>
+                <a16:creationId xmlns:a16="http://schemas.microsoft.com/office/drawing/2014/main" id="{9D9BBCF0-05A4-4738-B97A-34E9AA07185E}"/>
               </a:ext>
             </a:extLst>
           </p:cNvPr>
@@ -1960,7 +1960,7 @@
           <p:cNvPr id="7" name="">
             <a:extLst xmlns:a="http://schemas.openxmlformats.org/drawingml/2006/main">
               <a:ext uri="{FF2B5EF4-FFF2-40B4-BE49-F238E27FC236}">
-                <a16:creationId xmlns:a16="http://schemas.microsoft.com/office/drawing/2014/main" id="{A427CAE7-53D0-4E1A-BAE4-618FD6503ACE}"/>
+                <a16:creationId xmlns:a16="http://schemas.microsoft.com/office/drawing/2014/main" id="{D22C672C-64A6-4A6D-B086-3FC7A523A439}"/>
               </a:ext>
             </a:extLst>
           </p:cNvPr>
@@ -2017,7 +2017,7 @@
           <p:cNvPr id="8" name="">
             <a:extLst xmlns:a="http://schemas.openxmlformats.org/drawingml/2006/main">
               <a:ext uri="{FF2B5EF4-FFF2-40B4-BE49-F238E27FC236}">
-                <a16:creationId xmlns:a16="http://schemas.microsoft.com/office/drawing/2014/main" id="{9E31E79F-8754-4C2D-BEDA-2A94BD079C3C}"/>
+                <a16:creationId xmlns:a16="http://schemas.microsoft.com/office/drawing/2014/main" id="{BF6BD2E6-1791-4D92-A4F0-DD395FF8990C}"/>
               </a:ext>
             </a:extLst>
           </p:cNvPr>
@@ -2072,7 +2072,7 @@
     </p:spTree>
     <p:extLst>
       <p:ext uri="{BB962C8B-B14F-4D97-AF65-F5344CB8AC3E}">
-        <p14:creationId xmlns:p14="http://schemas.microsoft.com/office/powerpoint/2010/main" val="618112719"/>
+        <p14:creationId xmlns:p14="http://schemas.microsoft.com/office/powerpoint/2010/main" val="686298574"/>
       </p:ext>
     </p:extLst>
   </p:cSld>
@@ -2103,7 +2103,7 @@
           <p:cNvPr id="10" name="">
             <a:extLst xmlns:a="http://schemas.openxmlformats.org/drawingml/2006/main">
               <a:ext uri="{FF2B5EF4-FFF2-40B4-BE49-F238E27FC236}">
-                <a16:creationId xmlns:a16="http://schemas.microsoft.com/office/drawing/2014/main" id="{110E409F-A8CF-4B4B-95AA-EAD688F87513}"/>
+                <a16:creationId xmlns:a16="http://schemas.microsoft.com/office/drawing/2014/main" id="{86873D14-849D-428F-96C8-B5E68E22EB31}"/>
               </a:ext>
             </a:extLst>
           </p:cNvPr>
@@ -2160,7 +2160,7 @@
           <p:cNvPr id="2" name="">
             <a:extLst xmlns:a="http://schemas.openxmlformats.org/drawingml/2006/main">
               <a:ext uri="{FF2B5EF4-FFF2-40B4-BE49-F238E27FC236}">
-                <a16:creationId xmlns:a16="http://schemas.microsoft.com/office/drawing/2014/main" id="{953EC154-AAC5-4819-A5D9-52E697BC9F01}"/>
+                <a16:creationId xmlns:a16="http://schemas.microsoft.com/office/drawing/2014/main" id="{551C2555-34FE-4AE3-88B8-223A72AD45F5}"/>
               </a:ext>
             </a:extLst>
           </p:cNvPr>
@@ -2217,7 +2217,7 @@
           <p:cNvPr id="3" name="">
             <a:extLst xmlns:a="http://schemas.openxmlformats.org/drawingml/2006/main">
               <a:ext uri="{FF2B5EF4-FFF2-40B4-BE49-F238E27FC236}">
-                <a16:creationId xmlns:a16="http://schemas.microsoft.com/office/drawing/2014/main" id="{B248E450-2654-4FC2-B737-E1336247ED38}"/>
+                <a16:creationId xmlns:a16="http://schemas.microsoft.com/office/drawing/2014/main" id="{9EC1E676-4CF0-472D-A42E-0937B16F3F93}"/>
               </a:ext>
             </a:extLst>
           </p:cNvPr>
@@ -2274,7 +2274,7 @@
           <p:cNvPr id="4" name="">
             <a:extLst xmlns:a="http://schemas.openxmlformats.org/drawingml/2006/main">
               <a:ext uri="{FF2B5EF4-FFF2-40B4-BE49-F238E27FC236}">
-                <a16:creationId xmlns:a16="http://schemas.microsoft.com/office/drawing/2014/main" id="{C8BB998E-395B-49FA-88F3-B4B863E5BE09}"/>
+                <a16:creationId xmlns:a16="http://schemas.microsoft.com/office/drawing/2014/main" id="{4F2B5D7F-10A5-40D0-9616-B791B6A944C1}"/>
               </a:ext>
             </a:extLst>
           </p:cNvPr>
@@ -2331,7 +2331,7 @@
           <p:cNvPr id="5" name="">
             <a:extLst xmlns:a="http://schemas.openxmlformats.org/drawingml/2006/main">
               <a:ext uri="{FF2B5EF4-FFF2-40B4-BE49-F238E27FC236}">
-                <a16:creationId xmlns:a16="http://schemas.microsoft.com/office/drawing/2014/main" id="{7276F938-7404-4D37-B8C0-A80C2EEF61AA}"/>
+                <a16:creationId xmlns:a16="http://schemas.microsoft.com/office/drawing/2014/main" id="{AD95EF11-392D-4AE1-AB1A-96CC9A8930A1}"/>
               </a:ext>
             </a:extLst>
           </p:cNvPr>
@@ -2388,7 +2388,7 @@
           <p:cNvPr id="6" name="">
             <a:extLst xmlns:a="http://schemas.openxmlformats.org/drawingml/2006/main">
               <a:ext uri="{FF2B5EF4-FFF2-40B4-BE49-F238E27FC236}">
-                <a16:creationId xmlns:a16="http://schemas.microsoft.com/office/drawing/2014/main" id="{434DE5C5-13F8-43BF-AF86-FEFF8046B761}"/>
+                <a16:creationId xmlns:a16="http://schemas.microsoft.com/office/drawing/2014/main" id="{95B6454A-BA5B-4363-A316-75C411FC534A}"/>
               </a:ext>
             </a:extLst>
           </p:cNvPr>
@@ -2445,7 +2445,7 @@
           <p:cNvPr id="7" name="">
             <a:extLst xmlns:a="http://schemas.openxmlformats.org/drawingml/2006/main">
               <a:ext uri="{FF2B5EF4-FFF2-40B4-BE49-F238E27FC236}">
-                <a16:creationId xmlns:a16="http://schemas.microsoft.com/office/drawing/2014/main" id="{9206EC5A-8700-42F1-9582-5A1A42FB27F5}"/>
+                <a16:creationId xmlns:a16="http://schemas.microsoft.com/office/drawing/2014/main" id="{74366049-8665-4C7C-8D7C-FCFE6264A6EA}"/>
               </a:ext>
             </a:extLst>
           </p:cNvPr>
@@ -2506,7 +2506,7 @@
           <p:nvPr/>
         </p:nvPicPr>
         <p:blipFill>
-          <a:blip xmlns:r="http://schemas.openxmlformats.org/officeDocument/2006/relationships" xmlns:a="http://schemas.openxmlformats.org/drawingml/2006/main" r:embed="R4f768d1b832447a7"/>
+          <a:blip xmlns:r="http://schemas.openxmlformats.org/officeDocument/2006/relationships" xmlns:a="http://schemas.openxmlformats.org/drawingml/2006/main" r:embed="R61c510d0016f4cac"/>
           <a:stretch xmlns:a="http://schemas.openxmlformats.org/drawingml/2006/main"/>
         </p:blipFill>
         <p:spPr>
@@ -2524,7 +2524,7 @@
           <p:cNvPr id="9" name="">
             <a:extLst xmlns:a="http://schemas.openxmlformats.org/drawingml/2006/main">
               <a:ext uri="{FF2B5EF4-FFF2-40B4-BE49-F238E27FC236}">
-                <a16:creationId xmlns:a16="http://schemas.microsoft.com/office/drawing/2014/main" id="{364E599F-13F1-401C-9605-6B91E755C8E0}"/>
+                <a16:creationId xmlns:a16="http://schemas.microsoft.com/office/drawing/2014/main" id="{E251F788-52A1-413C-AB13-CC8D3F8964A4}"/>
               </a:ext>
             </a:extLst>
           </p:cNvPr>
@@ -2579,7 +2579,7 @@
     </p:spTree>
     <p:extLst>
       <p:ext uri="{BB962C8B-B14F-4D97-AF65-F5344CB8AC3E}">
-        <p14:creationId xmlns:p14="http://schemas.microsoft.com/office/powerpoint/2010/main" val="1844974708"/>
+        <p14:creationId xmlns:p14="http://schemas.microsoft.com/office/powerpoint/2010/main" val="1045795931"/>
       </p:ext>
     </p:extLst>
   </p:cSld>
@@ -2610,7 +2610,7 @@
           <p:cNvPr id="11" name="">
             <a:extLst xmlns:a="http://schemas.openxmlformats.org/drawingml/2006/main">
               <a:ext uri="{FF2B5EF4-FFF2-40B4-BE49-F238E27FC236}">
-                <a16:creationId xmlns:a16="http://schemas.microsoft.com/office/drawing/2014/main" id="{433616C0-3743-4ABE-956E-7D9AF54C447E}"/>
+                <a16:creationId xmlns:a16="http://schemas.microsoft.com/office/drawing/2014/main" id="{F77E82DB-C2D8-4A28-9C40-EC0E92587200}"/>
               </a:ext>
             </a:extLst>
           </p:cNvPr>
@@ -2667,7 +2667,7 @@
           <p:cNvPr id="2" name="">
             <a:extLst xmlns:a="http://schemas.openxmlformats.org/drawingml/2006/main">
               <a:ext uri="{FF2B5EF4-FFF2-40B4-BE49-F238E27FC236}">
-                <a16:creationId xmlns:a16="http://schemas.microsoft.com/office/drawing/2014/main" id="{56319E6D-5B59-4001-A304-12C69A3045B5}"/>
+                <a16:creationId xmlns:a16="http://schemas.microsoft.com/office/drawing/2014/main" id="{0383B63C-E5FF-4BF6-8047-DD7BA1DB34B2}"/>
               </a:ext>
             </a:extLst>
           </p:cNvPr>
@@ -2724,7 +2724,7 @@
           <p:cNvPr id="3" name="">
             <a:extLst xmlns:a="http://schemas.openxmlformats.org/drawingml/2006/main">
               <a:ext uri="{FF2B5EF4-FFF2-40B4-BE49-F238E27FC236}">
-                <a16:creationId xmlns:a16="http://schemas.microsoft.com/office/drawing/2014/main" id="{1AC36309-CFF3-4EB3-9AB1-3834D30317B4}"/>
+                <a16:creationId xmlns:a16="http://schemas.microsoft.com/office/drawing/2014/main" id="{7BF06086-295F-4E43-A2DB-224401C33AAA}"/>
               </a:ext>
             </a:extLst>
           </p:cNvPr>
@@ -2781,7 +2781,7 @@
           <p:cNvPr id="4" name="">
             <a:extLst xmlns:a="http://schemas.openxmlformats.org/drawingml/2006/main">
               <a:ext uri="{FF2B5EF4-FFF2-40B4-BE49-F238E27FC236}">
-                <a16:creationId xmlns:a16="http://schemas.microsoft.com/office/drawing/2014/main" id="{01972FDF-798A-494E-A979-EC73A43B33DD}"/>
+                <a16:creationId xmlns:a16="http://schemas.microsoft.com/office/drawing/2014/main" id="{6E485E9F-53E1-4B2B-97AE-B682FA2D7A09}"/>
               </a:ext>
             </a:extLst>
           </p:cNvPr>
@@ -2838,7 +2838,7 @@
           <p:cNvPr id="5" name="">
             <a:extLst xmlns:a="http://schemas.openxmlformats.org/drawingml/2006/main">
               <a:ext uri="{FF2B5EF4-FFF2-40B4-BE49-F238E27FC236}">
-                <a16:creationId xmlns:a16="http://schemas.microsoft.com/office/drawing/2014/main" id="{2CE8A389-E904-49AE-9625-81CD8E8F71FE}"/>
+                <a16:creationId xmlns:a16="http://schemas.microsoft.com/office/drawing/2014/main" id="{53BF2438-DE60-4DE3-ABF3-3A0FE3EBB619}"/>
               </a:ext>
             </a:extLst>
           </p:cNvPr>
@@ -2918,7 +2918,7 @@
           <p:cNvPr id="6" name="">
             <a:extLst xmlns:a="http://schemas.openxmlformats.org/drawingml/2006/main">
               <a:ext uri="{FF2B5EF4-FFF2-40B4-BE49-F238E27FC236}">
-                <a16:creationId xmlns:a16="http://schemas.microsoft.com/office/drawing/2014/main" id="{3C034439-9026-46E9-9D6E-C1A231CA3BA1}"/>
+                <a16:creationId xmlns:a16="http://schemas.microsoft.com/office/drawing/2014/main" id="{32A8074E-38A6-4CDC-8880-EE49BD58794B}"/>
               </a:ext>
             </a:extLst>
           </p:cNvPr>
@@ -2975,7 +2975,7 @@
           <p:cNvPr id="7" name="">
             <a:extLst xmlns:a="http://schemas.openxmlformats.org/drawingml/2006/main">
               <a:ext uri="{FF2B5EF4-FFF2-40B4-BE49-F238E27FC236}">
-                <a16:creationId xmlns:a16="http://schemas.microsoft.com/office/drawing/2014/main" id="{992BC03E-0468-4A2F-A1D4-7A17FBDA623E}"/>
+                <a16:creationId xmlns:a16="http://schemas.microsoft.com/office/drawing/2014/main" id="{4603B821-4C38-4E2B-90F4-187E2574DE4D}"/>
               </a:ext>
             </a:extLst>
           </p:cNvPr>
@@ -3036,7 +3036,7 @@
           <p:nvPr/>
         </p:nvPicPr>
         <p:blipFill>
-          <a:blip xmlns:r="http://schemas.openxmlformats.org/officeDocument/2006/relationships" xmlns:a="http://schemas.openxmlformats.org/drawingml/2006/main" r:embed="Rb8b1ff00fc984a47"/>
+          <a:blip xmlns:r="http://schemas.openxmlformats.org/officeDocument/2006/relationships" xmlns:a="http://schemas.openxmlformats.org/drawingml/2006/main" r:embed="R4193dc93bd0845c1"/>
           <a:srcRect xmlns:a="http://schemas.openxmlformats.org/drawingml/2006/main" l="0" t="24705" r="0" b="24705"/>
           <a:stretch xmlns:a="http://schemas.openxmlformats.org/drawingml/2006/main">
             <a:fillRect l="0" t="0" r="0" b="0"/>
@@ -3057,7 +3057,7 @@
           <p:cNvPr id="9" name="">
             <a:extLst xmlns:a="http://schemas.openxmlformats.org/drawingml/2006/main">
               <a:ext uri="{FF2B5EF4-FFF2-40B4-BE49-F238E27FC236}">
-                <a16:creationId xmlns:a16="http://schemas.microsoft.com/office/drawing/2014/main" id="{6B678980-287D-4490-98FD-844CE6156BF8}"/>
+                <a16:creationId xmlns:a16="http://schemas.microsoft.com/office/drawing/2014/main" id="{EE5D1AC8-4DD0-432E-B6CB-6F7555714620}"/>
               </a:ext>
             </a:extLst>
           </p:cNvPr>
@@ -3114,7 +3114,7 @@
           <p:cNvPr id="10" name="">
             <a:extLst xmlns:a="http://schemas.openxmlformats.org/drawingml/2006/main">
               <a:ext uri="{FF2B5EF4-FFF2-40B4-BE49-F238E27FC236}">
-                <a16:creationId xmlns:a16="http://schemas.microsoft.com/office/drawing/2014/main" id="{59CE44F6-4528-46C4-8BDC-A415797E860E}"/>
+                <a16:creationId xmlns:a16="http://schemas.microsoft.com/office/drawing/2014/main" id="{9DB883D0-ACEF-4420-B53E-F9B1E3991606}"/>
               </a:ext>
             </a:extLst>
           </p:cNvPr>
@@ -3169,7 +3169,7 @@
     </p:spTree>
     <p:extLst>
       <p:ext uri="{BB962C8B-B14F-4D97-AF65-F5344CB8AC3E}">
-        <p14:creationId xmlns:p14="http://schemas.microsoft.com/office/powerpoint/2010/main" val="1195152155"/>
+        <p14:creationId xmlns:p14="http://schemas.microsoft.com/office/powerpoint/2010/main" val="50456875"/>
       </p:ext>
     </p:extLst>
   </p:cSld>
@@ -3200,7 +3200,7 @@
           <p:cNvPr id="17" name="">
             <a:extLst xmlns:a="http://schemas.openxmlformats.org/drawingml/2006/main">
               <a:ext uri="{FF2B5EF4-FFF2-40B4-BE49-F238E27FC236}">
-                <a16:creationId xmlns:a16="http://schemas.microsoft.com/office/drawing/2014/main" id="{BF42D359-3EC5-48D4-82A0-E36E7A229642}"/>
+                <a16:creationId xmlns:a16="http://schemas.microsoft.com/office/drawing/2014/main" id="{222DFC20-456B-4CE3-A403-0F17DFFFA00B}"/>
               </a:ext>
             </a:extLst>
           </p:cNvPr>
@@ -3257,7 +3257,7 @@
           <p:cNvPr id="2" name="">
             <a:extLst xmlns:a="http://schemas.openxmlformats.org/drawingml/2006/main">
               <a:ext uri="{FF2B5EF4-FFF2-40B4-BE49-F238E27FC236}">
-                <a16:creationId xmlns:a16="http://schemas.microsoft.com/office/drawing/2014/main" id="{301716C3-1D2D-41DB-9394-80B8DE17D33B}"/>
+                <a16:creationId xmlns:a16="http://schemas.microsoft.com/office/drawing/2014/main" id="{222C5DFC-4668-40AC-8652-2FCE1C1ADA06}"/>
               </a:ext>
             </a:extLst>
           </p:cNvPr>
@@ -3314,7 +3314,7 @@
           <p:cNvPr id="3" name="">
             <a:extLst xmlns:a="http://schemas.openxmlformats.org/drawingml/2006/main">
               <a:ext uri="{FF2B5EF4-FFF2-40B4-BE49-F238E27FC236}">
-                <a16:creationId xmlns:a16="http://schemas.microsoft.com/office/drawing/2014/main" id="{76B499E3-3E99-49D5-B201-00AC352E31D1}"/>
+                <a16:creationId xmlns:a16="http://schemas.microsoft.com/office/drawing/2014/main" id="{2E357A96-4ED4-4E90-AC0C-D02323EC0059}"/>
               </a:ext>
             </a:extLst>
           </p:cNvPr>
@@ -3371,7 +3371,7 @@
           <p:cNvPr id="4" name="">
             <a:extLst xmlns:a="http://schemas.openxmlformats.org/drawingml/2006/main">
               <a:ext uri="{FF2B5EF4-FFF2-40B4-BE49-F238E27FC236}">
-                <a16:creationId xmlns:a16="http://schemas.microsoft.com/office/drawing/2014/main" id="{172AFD64-8B5F-4D6B-B02A-5044CA4ACA01}"/>
+                <a16:creationId xmlns:a16="http://schemas.microsoft.com/office/drawing/2014/main" id="{D540A2F0-9745-441B-B2CE-D0DB0E83EEC4}"/>
               </a:ext>
             </a:extLst>
           </p:cNvPr>
@@ -3428,7 +3428,7 @@
           <p:cNvPr id="5" name="">
             <a:extLst xmlns:a="http://schemas.openxmlformats.org/drawingml/2006/main">
               <a:ext uri="{FF2B5EF4-FFF2-40B4-BE49-F238E27FC236}">
-                <a16:creationId xmlns:a16="http://schemas.microsoft.com/office/drawing/2014/main" id="{CA2936D8-3814-4879-8628-5BE9A2759FA5}"/>
+                <a16:creationId xmlns:a16="http://schemas.microsoft.com/office/drawing/2014/main" id="{0C52AADB-964A-42DB-956C-A8B25A49D419}"/>
               </a:ext>
             </a:extLst>
           </p:cNvPr>
@@ -3485,7 +3485,7 @@
           <p:cNvPr id="6" name="">
             <a:extLst xmlns:a="http://schemas.openxmlformats.org/drawingml/2006/main">
               <a:ext uri="{FF2B5EF4-FFF2-40B4-BE49-F238E27FC236}">
-                <a16:creationId xmlns:a16="http://schemas.microsoft.com/office/drawing/2014/main" id="{194989D2-E2DA-4923-8B71-496DE61168F5}"/>
+                <a16:creationId xmlns:a16="http://schemas.microsoft.com/office/drawing/2014/main" id="{2EA28D64-AB3F-4466-A0EA-6FE7D20798B8}"/>
               </a:ext>
             </a:extLst>
           </p:cNvPr>
@@ -3542,7 +3542,7 @@
           <p:cNvPr id="7" name="">
             <a:extLst xmlns:a="http://schemas.openxmlformats.org/drawingml/2006/main">
               <a:ext uri="{FF2B5EF4-FFF2-40B4-BE49-F238E27FC236}">
-                <a16:creationId xmlns:a16="http://schemas.microsoft.com/office/drawing/2014/main" id="{3DA2BE25-81E3-4976-941F-B93E455ADCF7}"/>
+                <a16:creationId xmlns:a16="http://schemas.microsoft.com/office/drawing/2014/main" id="{91A24D90-9509-495C-AD9A-03925A00BF49}"/>
               </a:ext>
             </a:extLst>
           </p:cNvPr>
@@ -3599,7 +3599,7 @@
           <p:cNvPr id="8" name="">
             <a:extLst xmlns:a="http://schemas.openxmlformats.org/drawingml/2006/main">
               <a:ext uri="{FF2B5EF4-FFF2-40B4-BE49-F238E27FC236}">
-                <a16:creationId xmlns:a16="http://schemas.microsoft.com/office/drawing/2014/main" id="{78ACE4BD-27DE-4FF7-A2D8-6160D9F82B49}"/>
+                <a16:creationId xmlns:a16="http://schemas.microsoft.com/office/drawing/2014/main" id="{674BD8EE-F172-44E1-95C2-8E2E978A4966}"/>
               </a:ext>
             </a:extLst>
           </p:cNvPr>
@@ -3656,7 +3656,7 @@
           <p:cNvPr id="9" name="">
             <a:extLst xmlns:a="http://schemas.openxmlformats.org/drawingml/2006/main">
               <a:ext uri="{FF2B5EF4-FFF2-40B4-BE49-F238E27FC236}">
-                <a16:creationId xmlns:a16="http://schemas.microsoft.com/office/drawing/2014/main" id="{81CB1EAF-66C7-4E96-B6EA-16841B006697}"/>
+                <a16:creationId xmlns:a16="http://schemas.microsoft.com/office/drawing/2014/main" id="{4CCDD923-9794-47CF-8B9D-7496C4EE3FF5}"/>
               </a:ext>
             </a:extLst>
           </p:cNvPr>
@@ -3713,7 +3713,7 @@
           <p:cNvPr id="10" name="">
             <a:extLst xmlns:a="http://schemas.openxmlformats.org/drawingml/2006/main">
               <a:ext uri="{FF2B5EF4-FFF2-40B4-BE49-F238E27FC236}">
-                <a16:creationId xmlns:a16="http://schemas.microsoft.com/office/drawing/2014/main" id="{F4666A81-E206-438D-A8FE-083F00A0B685}"/>
+                <a16:creationId xmlns:a16="http://schemas.microsoft.com/office/drawing/2014/main" id="{2E66842E-B196-42DC-888E-9DF702AFCFEF}"/>
               </a:ext>
             </a:extLst>
           </p:cNvPr>
@@ -3770,7 +3770,7 @@
           <p:cNvPr id="11" name="">
             <a:extLst xmlns:a="http://schemas.openxmlformats.org/drawingml/2006/main">
               <a:ext uri="{FF2B5EF4-FFF2-40B4-BE49-F238E27FC236}">
-                <a16:creationId xmlns:a16="http://schemas.microsoft.com/office/drawing/2014/main" id="{445ACCE2-27F6-4620-8E4E-3DAC2BDDFBD6}"/>
+                <a16:creationId xmlns:a16="http://schemas.microsoft.com/office/drawing/2014/main" id="{34639559-3A1B-4DB4-A983-4CC2CF770F75}"/>
               </a:ext>
             </a:extLst>
           </p:cNvPr>
@@ -3827,7 +3827,7 @@
           <p:cNvPr id="12" name="">
             <a:extLst xmlns:a="http://schemas.openxmlformats.org/drawingml/2006/main">
               <a:ext uri="{FF2B5EF4-FFF2-40B4-BE49-F238E27FC236}">
-                <a16:creationId xmlns:a16="http://schemas.microsoft.com/office/drawing/2014/main" id="{4408C85C-D6C8-48DC-B31E-758D5C7F29C6}"/>
+                <a16:creationId xmlns:a16="http://schemas.microsoft.com/office/drawing/2014/main" id="{2673A4F9-D2C6-4772-8384-D5A790DC22F8}"/>
               </a:ext>
             </a:extLst>
           </p:cNvPr>
@@ -3884,7 +3884,7 @@
           <p:cNvPr id="13" name="">
             <a:extLst xmlns:a="http://schemas.openxmlformats.org/drawingml/2006/main">
               <a:ext uri="{FF2B5EF4-FFF2-40B4-BE49-F238E27FC236}">
-                <a16:creationId xmlns:a16="http://schemas.microsoft.com/office/drawing/2014/main" id="{C2E19528-2512-4752-A8C0-4A1745769B3F}"/>
+                <a16:creationId xmlns:a16="http://schemas.microsoft.com/office/drawing/2014/main" id="{6533596A-CF73-44AB-8E7C-EECDA48EE222}"/>
               </a:ext>
             </a:extLst>
           </p:cNvPr>
@@ -3941,7 +3941,7 @@
           <p:cNvPr id="14" name="">
             <a:extLst xmlns:a="http://schemas.openxmlformats.org/drawingml/2006/main">
               <a:ext uri="{FF2B5EF4-FFF2-40B4-BE49-F238E27FC236}">
-                <a16:creationId xmlns:a16="http://schemas.microsoft.com/office/drawing/2014/main" id="{702D94CE-8C30-45D9-9696-EA980D6A8762}"/>
+                <a16:creationId xmlns:a16="http://schemas.microsoft.com/office/drawing/2014/main" id="{516DBD94-B592-4163-8F70-77C1AEF949A2}"/>
               </a:ext>
             </a:extLst>
           </p:cNvPr>
@@ -3998,7 +3998,7 @@
           <p:cNvPr id="15" name="">
             <a:extLst xmlns:a="http://schemas.openxmlformats.org/drawingml/2006/main">
               <a:ext uri="{FF2B5EF4-FFF2-40B4-BE49-F238E27FC236}">
-                <a16:creationId xmlns:a16="http://schemas.microsoft.com/office/drawing/2014/main" id="{CE929835-599A-4838-B44E-CF98830D2088}"/>
+                <a16:creationId xmlns:a16="http://schemas.microsoft.com/office/drawing/2014/main" id="{5650FE12-ABC4-4294-A300-00B5D0E723B3}"/>
               </a:ext>
             </a:extLst>
           </p:cNvPr>
@@ -4055,36 +4055,36 @@
           <p:cNvPr id="16" name="">
             <a:extLst xmlns:a="http://schemas.openxmlformats.org/drawingml/2006/main">
               <a:ext uri="{FF2B5EF4-FFF2-40B4-BE49-F238E27FC236}">
-                <a16:creationId xmlns:a16="http://schemas.microsoft.com/office/drawing/2014/main" id="{5F113F74-EEAB-447E-968F-24A1B0CE6137}"/>
-              </a:ext>
-            </a:extLst>
-          </p:cNvPr>
-          <p:cNvSpPr>
-            <a:spLocks xmlns:a="http://schemas.openxmlformats.org/drawingml/2006/main" noGrp="1"/>
-          </p:cNvSpPr>
-          <p:nvPr/>
-        </p:nvSpPr>
-        <p:spPr>
-          <a:xfrm xmlns:a="http://schemas.openxmlformats.org/drawingml/2006/main">
-            <a:off x="1552575" y="6134100"/>
-            <a:ext cx="9763125" cy="285750"/>
-          </a:xfrm>
-          <a:prstGeom xmlns:a="http://schemas.openxmlformats.org/drawingml/2006/main" prst="rect">
-            <a:avLst/>
-          </a:prstGeom>
-          <a:noFill xmlns:a="http://schemas.openxmlformats.org/drawingml/2006/main"/>
-          <a:ln xmlns:a="http://schemas.openxmlformats.org/drawingml/2006/main" w="0">
-            <a:noFill/>
-          </a:ln>
-        </p:spPr>
-        <p:txBody>
-          <a:bodyPr xmlns:a="http://schemas.openxmlformats.org/drawingml/2006/main">
-            <a:noAutofit/>
-          </a:bodyPr>
-          <a:lstStyle xmlns:a="http://schemas.openxmlformats.org/drawingml/2006/main"/>
-          <a:p xmlns:a="http://schemas.openxmlformats.org/drawingml/2006/main">
-            <a:pPr>
-              <a:defRPr sz="1500" b="0">
+                <a16:creationId xmlns:a16="http://schemas.microsoft.com/office/drawing/2014/main" id="{97929EBE-612A-4991-B845-7E8B848D6BD3}"/>
+              </a:ext>
+            </a:extLst>
+          </p:cNvPr>
+          <p:cNvSpPr>
+            <a:spLocks xmlns:a="http://schemas.openxmlformats.org/drawingml/2006/main" noGrp="1"/>
+          </p:cNvSpPr>
+          <p:nvPr/>
+        </p:nvSpPr>
+        <p:spPr>
+          <a:xfrm xmlns:a="http://schemas.openxmlformats.org/drawingml/2006/main">
+            <a:off x="1552575" y="6019800"/>
+            <a:ext cx="9763125" cy="542925"/>
+          </a:xfrm>
+          <a:prstGeom xmlns:a="http://schemas.openxmlformats.org/drawingml/2006/main" prst="rect">
+            <a:avLst/>
+          </a:prstGeom>
+          <a:noFill xmlns:a="http://schemas.openxmlformats.org/drawingml/2006/main"/>
+          <a:ln xmlns:a="http://schemas.openxmlformats.org/drawingml/2006/main" w="0">
+            <a:noFill/>
+          </a:ln>
+        </p:spPr>
+        <p:txBody>
+          <a:bodyPr xmlns:a="http://schemas.openxmlformats.org/drawingml/2006/main">
+            <a:noAutofit/>
+          </a:bodyPr>
+          <a:lstStyle xmlns:a="http://schemas.openxmlformats.org/drawingml/2006/main"/>
+          <a:p xmlns:a="http://schemas.openxmlformats.org/drawingml/2006/main">
+            <a:pPr>
+              <a:defRPr sz="1425" b="0">
                 <a:solidFill>
                   <a:srgbClr val="66715F"/>
                 </a:solidFill>
@@ -4094,7 +4094,7 @@
               </a:defRPr>
             </a:pPr>
             <a:r>
-              <a:rPr sz="1500" b="0">
+              <a:rPr sz="1425" b="0">
                 <a:solidFill>
                   <a:srgbClr val="66715F"/>
                 </a:solidFill>
@@ -4102,7 +4102,30 @@
                 <a:ea typeface="Helvetica Neue"/>
                 <a:cs typeface="Helvetica Neue"/>
               </a:rPr>
-              <a:t>Immutable source and inventory snapshots preserve the inputs behind each response.</a:t>
+              <a:t>Firebase Auth for sign-in. Cloud Run API with Firestore storage.</a:t>
+            </a:r>
+          </a:p>
+          <a:p xmlns:a="http://schemas.openxmlformats.org/drawingml/2006/main">
+            <a:pPr>
+              <a:defRPr sz="1425" b="0">
+                <a:solidFill>
+                  <a:srgbClr val="66715F"/>
+                </a:solidFill>
+                <a:latin typeface="Helvetica Neue"/>
+                <a:ea typeface="Helvetica Neue"/>
+                <a:cs typeface="Helvetica Neue"/>
+              </a:defRPr>
+            </a:pPr>
+            <a:r>
+              <a:rPr sz="1425" b="0">
+                <a:solidFill>
+                  <a:srgbClr val="66715F"/>
+                </a:solidFill>
+                <a:latin typeface="Helvetica Neue"/>
+                <a:ea typeface="Helvetica Neue"/>
+                <a:cs typeface="Helvetica Neue"/>
+              </a:rPr>
+              <a:t>Immutable source and inventory snapshots preserve each response’s inputs.</a:t>
             </a:r>
           </a:p>
         </p:txBody>
@@ -4110,7 +4133,7 @@
     </p:spTree>
     <p:extLst>
       <p:ext uri="{BB962C8B-B14F-4D97-AF65-F5344CB8AC3E}">
-        <p14:creationId xmlns:p14="http://schemas.microsoft.com/office/powerpoint/2010/main" val="354007679"/>
+        <p14:creationId xmlns:p14="http://schemas.microsoft.com/office/powerpoint/2010/main" val="11393659"/>
       </p:ext>
     </p:extLst>
   </p:cSld>
@@ -4141,7 +4164,7 @@
           <p:cNvPr id="11" name="">
             <a:extLst xmlns:a="http://schemas.openxmlformats.org/drawingml/2006/main">
               <a:ext uri="{FF2B5EF4-FFF2-40B4-BE49-F238E27FC236}">
-                <a16:creationId xmlns:a16="http://schemas.microsoft.com/office/drawing/2014/main" id="{93B8C5BD-A08C-49CD-94B0-7AA85C24F891}"/>
+                <a16:creationId xmlns:a16="http://schemas.microsoft.com/office/drawing/2014/main" id="{22861BA4-D924-4138-9889-2A5F63D9A6FA}"/>
               </a:ext>
             </a:extLst>
           </p:cNvPr>
@@ -4198,7 +4221,7 @@
           <p:cNvPr id="2" name="">
             <a:extLst xmlns:a="http://schemas.openxmlformats.org/drawingml/2006/main">
               <a:ext uri="{FF2B5EF4-FFF2-40B4-BE49-F238E27FC236}">
-                <a16:creationId xmlns:a16="http://schemas.microsoft.com/office/drawing/2014/main" id="{906D401B-3077-424D-8D49-53CCCCA9C093}"/>
+                <a16:creationId xmlns:a16="http://schemas.microsoft.com/office/drawing/2014/main" id="{8AD5F327-0C03-4A32-9720-D72149841B60}"/>
               </a:ext>
             </a:extLst>
           </p:cNvPr>
@@ -4255,7 +4278,7 @@
           <p:cNvPr id="3" name="">
             <a:extLst xmlns:a="http://schemas.openxmlformats.org/drawingml/2006/main">
               <a:ext uri="{FF2B5EF4-FFF2-40B4-BE49-F238E27FC236}">
-                <a16:creationId xmlns:a16="http://schemas.microsoft.com/office/drawing/2014/main" id="{57185ED1-363E-4695-9BE7-B4CB41B96EDF}"/>
+                <a16:creationId xmlns:a16="http://schemas.microsoft.com/office/drawing/2014/main" id="{7C56DD96-76D3-4466-9CF8-EBACEAC6B98F}"/>
               </a:ext>
             </a:extLst>
           </p:cNvPr>
@@ -4312,7 +4335,7 @@
           <p:cNvPr id="4" name="">
             <a:extLst xmlns:a="http://schemas.openxmlformats.org/drawingml/2006/main">
               <a:ext uri="{FF2B5EF4-FFF2-40B4-BE49-F238E27FC236}">
-                <a16:creationId xmlns:a16="http://schemas.microsoft.com/office/drawing/2014/main" id="{A7B5E679-3FBD-4B77-BFA3-DAC6E577582E}"/>
+                <a16:creationId xmlns:a16="http://schemas.microsoft.com/office/drawing/2014/main" id="{B9C743F7-AEB4-4206-B616-DB0724B71073}"/>
               </a:ext>
             </a:extLst>
           </p:cNvPr>
@@ -4369,7 +4392,7 @@
           <p:cNvPr id="5" name="">
             <a:extLst xmlns:a="http://schemas.openxmlformats.org/drawingml/2006/main">
               <a:ext uri="{FF2B5EF4-FFF2-40B4-BE49-F238E27FC236}">
-                <a16:creationId xmlns:a16="http://schemas.microsoft.com/office/drawing/2014/main" id="{0348BA0E-EC94-49E5-B28E-6A9D42504498}"/>
+                <a16:creationId xmlns:a16="http://schemas.microsoft.com/office/drawing/2014/main" id="{CDC3D1DE-7223-498F-8614-5F6B76A630C1}"/>
               </a:ext>
             </a:extLst>
           </p:cNvPr>
@@ -4426,7 +4449,7 @@
           <p:cNvPr id="6" name="">
             <a:extLst xmlns:a="http://schemas.openxmlformats.org/drawingml/2006/main">
               <a:ext uri="{FF2B5EF4-FFF2-40B4-BE49-F238E27FC236}">
-                <a16:creationId xmlns:a16="http://schemas.microsoft.com/office/drawing/2014/main" id="{CC4D08EA-DC83-4B6E-B8E8-9A1D3626259A}"/>
+                <a16:creationId xmlns:a16="http://schemas.microsoft.com/office/drawing/2014/main" id="{9EAFC12B-F7DC-42A4-86FB-836256084FBB}"/>
               </a:ext>
             </a:extLst>
           </p:cNvPr>
@@ -4483,7 +4506,7 @@
           <p:cNvPr id="7" name="">
             <a:extLst xmlns:a="http://schemas.openxmlformats.org/drawingml/2006/main">
               <a:ext uri="{FF2B5EF4-FFF2-40B4-BE49-F238E27FC236}">
-                <a16:creationId xmlns:a16="http://schemas.microsoft.com/office/drawing/2014/main" id="{B9708AAE-9AA4-45EB-BCCC-42B8C44B4DFB}"/>
+                <a16:creationId xmlns:a16="http://schemas.microsoft.com/office/drawing/2014/main" id="{77E96EFE-4556-41DD-AAAB-F746FAF3D5D8}"/>
               </a:ext>
             </a:extLst>
           </p:cNvPr>
@@ -4540,7 +4563,7 @@
           <p:cNvPr id="8" name="">
             <a:extLst xmlns:a="http://schemas.openxmlformats.org/drawingml/2006/main">
               <a:ext uri="{FF2B5EF4-FFF2-40B4-BE49-F238E27FC236}">
-                <a16:creationId xmlns:a16="http://schemas.microsoft.com/office/drawing/2014/main" id="{7E192FD4-1904-481F-9D78-1A796861078E}"/>
+                <a16:creationId xmlns:a16="http://schemas.microsoft.com/office/drawing/2014/main" id="{52B800AD-590A-4700-9F9C-FD3B4BC420CA}"/>
               </a:ext>
             </a:extLst>
           </p:cNvPr>
@@ -4620,7 +4643,7 @@
           <p:cNvPr id="9" name="">
             <a:extLst xmlns:a="http://schemas.openxmlformats.org/drawingml/2006/main">
               <a:ext uri="{FF2B5EF4-FFF2-40B4-BE49-F238E27FC236}">
-                <a16:creationId xmlns:a16="http://schemas.microsoft.com/office/drawing/2014/main" id="{DE1424E2-57E5-40D0-A27D-D733074828AD}"/>
+                <a16:creationId xmlns:a16="http://schemas.microsoft.com/office/drawing/2014/main" id="{9E073C1A-FAE2-41CE-ACBF-CEBBF1C3073F}"/>
               </a:ext>
             </a:extLst>
           </p:cNvPr>
@@ -4677,7 +4700,7 @@
           <p:cNvPr id="10" name="">
             <a:extLst xmlns:a="http://schemas.openxmlformats.org/drawingml/2006/main">
               <a:ext uri="{FF2B5EF4-FFF2-40B4-BE49-F238E27FC236}">
-                <a16:creationId xmlns:a16="http://schemas.microsoft.com/office/drawing/2014/main" id="{28BE9F85-66F0-458D-A7FE-B359AC7C2D81}"/>
+                <a16:creationId xmlns:a16="http://schemas.microsoft.com/office/drawing/2014/main" id="{8121C824-1048-45BF-8AF5-67C5D2B008CE}"/>
               </a:ext>
             </a:extLst>
           </p:cNvPr>
@@ -4755,7 +4778,7 @@
     </p:spTree>
     <p:extLst>
       <p:ext uri="{BB962C8B-B14F-4D97-AF65-F5344CB8AC3E}">
-        <p14:creationId xmlns:p14="http://schemas.microsoft.com/office/powerpoint/2010/main" val="1664280417"/>
+        <p14:creationId xmlns:p14="http://schemas.microsoft.com/office/powerpoint/2010/main" val="399749672"/>
       </p:ext>
     </p:extLst>
   </p:cSld>
@@ -4786,7 +4809,7 @@
           <p:cNvPr id="11" name="">
             <a:extLst xmlns:a="http://schemas.openxmlformats.org/drawingml/2006/main">
               <a:ext uri="{FF2B5EF4-FFF2-40B4-BE49-F238E27FC236}">
-                <a16:creationId xmlns:a16="http://schemas.microsoft.com/office/drawing/2014/main" id="{27BF10E4-7093-420F-9328-A00A5C549012}"/>
+                <a16:creationId xmlns:a16="http://schemas.microsoft.com/office/drawing/2014/main" id="{B491E99F-6DD6-4F2C-9BFE-2742871B1976}"/>
               </a:ext>
             </a:extLst>
           </p:cNvPr>
@@ -4843,7 +4866,7 @@
           <p:cNvPr id="2" name="">
             <a:extLst xmlns:a="http://schemas.openxmlformats.org/drawingml/2006/main">
               <a:ext uri="{FF2B5EF4-FFF2-40B4-BE49-F238E27FC236}">
-                <a16:creationId xmlns:a16="http://schemas.microsoft.com/office/drawing/2014/main" id="{B1DE7506-3CB8-4A56-84E5-2F204A8020B9}"/>
+                <a16:creationId xmlns:a16="http://schemas.microsoft.com/office/drawing/2014/main" id="{7ACEF5B9-9030-4B6F-81BF-E688783A87C5}"/>
               </a:ext>
             </a:extLst>
           </p:cNvPr>
@@ -4900,7 +4923,7 @@
           <p:cNvPr id="3" name="">
             <a:extLst xmlns:a="http://schemas.openxmlformats.org/drawingml/2006/main">
               <a:ext uri="{FF2B5EF4-FFF2-40B4-BE49-F238E27FC236}">
-                <a16:creationId xmlns:a16="http://schemas.microsoft.com/office/drawing/2014/main" id="{3698A715-85EC-440B-8323-5854AADDD2AB}"/>
+                <a16:creationId xmlns:a16="http://schemas.microsoft.com/office/drawing/2014/main" id="{58E6DED5-5838-49BC-B1EA-06185CAF9D2B}"/>
               </a:ext>
             </a:extLst>
           </p:cNvPr>
@@ -4957,7 +4980,7 @@
           <p:cNvPr id="4" name="">
             <a:extLst xmlns:a="http://schemas.openxmlformats.org/drawingml/2006/main">
               <a:ext uri="{FF2B5EF4-FFF2-40B4-BE49-F238E27FC236}">
-                <a16:creationId xmlns:a16="http://schemas.microsoft.com/office/drawing/2014/main" id="{78C5F206-C8BB-418C-86C3-88862E2A433F}"/>
+                <a16:creationId xmlns:a16="http://schemas.microsoft.com/office/drawing/2014/main" id="{C90BFA42-1DA3-47A7-81B2-C961C322975B}"/>
               </a:ext>
             </a:extLst>
           </p:cNvPr>
@@ -5004,7 +5027,7 @@
                 <a:ea typeface="Helvetica Neue"/>
                 <a:cs typeface="Helvetica Neue"/>
               </a:rPr>
-              <a:t>33</a:t>
+              <a:t>36</a:t>
             </a:r>
           </a:p>
         </p:txBody>
@@ -5014,7 +5037,7 @@
           <p:cNvPr id="5" name="">
             <a:extLst xmlns:a="http://schemas.openxmlformats.org/drawingml/2006/main">
               <a:ext uri="{FF2B5EF4-FFF2-40B4-BE49-F238E27FC236}">
-                <a16:creationId xmlns:a16="http://schemas.microsoft.com/office/drawing/2014/main" id="{6DEEB0E5-122C-41B9-A814-63642EE3F342}"/>
+                <a16:creationId xmlns:a16="http://schemas.microsoft.com/office/drawing/2014/main" id="{EEDBDE19-95F9-4A2E-B8EE-FE2DA20AF879}"/>
               </a:ext>
             </a:extLst>
           </p:cNvPr>
@@ -5061,7 +5084,7 @@
                 <a:ea typeface="Helvetica Neue"/>
                 <a:cs typeface="Helvetica Neue"/>
               </a:rPr>
-              <a:t>automated logic checks pass</a:t>
+              <a:t>automated unit tests pass</a:t>
             </a:r>
           </a:p>
         </p:txBody>
@@ -5071,7 +5094,7 @@
           <p:cNvPr id="6" name="">
             <a:extLst xmlns:a="http://schemas.openxmlformats.org/drawingml/2006/main">
               <a:ext uri="{FF2B5EF4-FFF2-40B4-BE49-F238E27FC236}">
-                <a16:creationId xmlns:a16="http://schemas.microsoft.com/office/drawing/2014/main" id="{799B2F2F-5777-447C-8B09-D72B8CDF5B9D}"/>
+                <a16:creationId xmlns:a16="http://schemas.microsoft.com/office/drawing/2014/main" id="{F7B4CF1A-6281-49B8-851E-D7EE0278DF9D}"/>
               </a:ext>
             </a:extLst>
           </p:cNvPr>
@@ -5118,7 +5141,7 @@
                 <a:ea typeface="Helvetica Neue"/>
                 <a:cs typeface="Helvetica Neue"/>
               </a:rPr>
-              <a:t>Browser checks pass for workflow, sign-in, persistence, exports and mobile use.</a:t>
+              <a:t>10 public Firebase browser tests pass across workflow, sign-in, persistence, exports and mobile use.</a:t>
             </a:r>
           </a:p>
         </p:txBody>
@@ -5128,7 +5151,7 @@
           <p:cNvPr id="7" name="">
             <a:extLst xmlns:a="http://schemas.openxmlformats.org/drawingml/2006/main">
               <a:ext uri="{FF2B5EF4-FFF2-40B4-BE49-F238E27FC236}">
-                <a16:creationId xmlns:a16="http://schemas.microsoft.com/office/drawing/2014/main" id="{116A3535-4444-4738-A1A6-7C32FA30AA01}"/>
+                <a16:creationId xmlns:a16="http://schemas.microsoft.com/office/drawing/2014/main" id="{30AFABA8-34BE-4D8F-8EC1-1DD31F740810}"/>
               </a:ext>
             </a:extLst>
           </p:cNvPr>
@@ -5185,7 +5208,7 @@
           <p:cNvPr id="8" name="">
             <a:extLst xmlns:a="http://schemas.openxmlformats.org/drawingml/2006/main">
               <a:ext uri="{FF2B5EF4-FFF2-40B4-BE49-F238E27FC236}">
-                <a16:creationId xmlns:a16="http://schemas.microsoft.com/office/drawing/2014/main" id="{BAA674BE-E3A1-47AB-AC5C-19762A35CF1E}"/>
+                <a16:creationId xmlns:a16="http://schemas.microsoft.com/office/drawing/2014/main" id="{DD16BE4C-ACE8-452C-A93A-95EF26B6CEA2}"/>
               </a:ext>
             </a:extLst>
           </p:cNvPr>
@@ -5288,7 +5311,7 @@
           <p:cNvPr id="9" name="">
             <a:extLst xmlns:a="http://schemas.openxmlformats.org/drawingml/2006/main">
               <a:ext uri="{FF2B5EF4-FFF2-40B4-BE49-F238E27FC236}">
-                <a16:creationId xmlns:a16="http://schemas.microsoft.com/office/drawing/2014/main" id="{ABF632C2-7EDF-4CA2-85F6-EDC34694F75A}"/>
+                <a16:creationId xmlns:a16="http://schemas.microsoft.com/office/drawing/2014/main" id="{507E56CD-98B5-418A-BBB7-DADE8C05B5F0}"/>
               </a:ext>
             </a:extLst>
           </p:cNvPr>
@@ -5345,7 +5368,7 @@
           <p:cNvPr id="10" name="">
             <a:extLst xmlns:a="http://schemas.openxmlformats.org/drawingml/2006/main">
               <a:ext uri="{FF2B5EF4-FFF2-40B4-BE49-F238E27FC236}">
-                <a16:creationId xmlns:a16="http://schemas.microsoft.com/office/drawing/2014/main" id="{A84F0AD7-4C85-40A0-AAF0-D74EF0DA77AB}"/>
+                <a16:creationId xmlns:a16="http://schemas.microsoft.com/office/drawing/2014/main" id="{D55FE8A3-3EE7-4011-9859-EC0603CDC16D}"/>
               </a:ext>
             </a:extLst>
           </p:cNvPr>
@@ -5400,7 +5423,7 @@
     </p:spTree>
     <p:extLst>
       <p:ext uri="{BB962C8B-B14F-4D97-AF65-F5344CB8AC3E}">
-        <p14:creationId xmlns:p14="http://schemas.microsoft.com/office/powerpoint/2010/main" val="750145972"/>
+        <p14:creationId xmlns:p14="http://schemas.microsoft.com/office/powerpoint/2010/main" val="2146711248"/>
       </p:ext>
     </p:extLst>
   </p:cSld>
@@ -5428,10 +5451,10 @@
       </p:grpSpPr>
       <p:sp>
         <p:nvSpPr>
-          <p:cNvPr id="8" name="">
-            <a:extLst xmlns:a="http://schemas.openxmlformats.org/drawingml/2006/main">
-              <a:ext uri="{FF2B5EF4-FFF2-40B4-BE49-F238E27FC236}">
-                <a16:creationId xmlns:a16="http://schemas.microsoft.com/office/drawing/2014/main" id="{16916232-DB91-4586-970C-F7076A3ED6BA}"/>
+          <p:cNvPr id="9" name="">
+            <a:extLst xmlns:a="http://schemas.openxmlformats.org/drawingml/2006/main">
+              <a:ext uri="{FF2B5EF4-FFF2-40B4-BE49-F238E27FC236}">
+                <a16:creationId xmlns:a16="http://schemas.microsoft.com/office/drawing/2014/main" id="{5C965DC1-89A4-435C-9346-214473D950CE}"/>
               </a:ext>
             </a:extLst>
           </p:cNvPr>
@@ -5488,7 +5511,7 @@
           <p:cNvPr id="2" name="">
             <a:extLst xmlns:a="http://schemas.openxmlformats.org/drawingml/2006/main">
               <a:ext uri="{FF2B5EF4-FFF2-40B4-BE49-F238E27FC236}">
-                <a16:creationId xmlns:a16="http://schemas.microsoft.com/office/drawing/2014/main" id="{F90543C5-12E0-4EE1-B7B5-E1F26CCF4691}"/>
+                <a16:creationId xmlns:a16="http://schemas.microsoft.com/office/drawing/2014/main" id="{4929A45B-F2B7-4D6D-8378-B6873AEF6A49}"/>
               </a:ext>
             </a:extLst>
           </p:cNvPr>
@@ -5545,7 +5568,7 @@
           <p:cNvPr id="3" name="">
             <a:extLst xmlns:a="http://schemas.openxmlformats.org/drawingml/2006/main">
               <a:ext uri="{FF2B5EF4-FFF2-40B4-BE49-F238E27FC236}">
-                <a16:creationId xmlns:a16="http://schemas.microsoft.com/office/drawing/2014/main" id="{7A83EA80-4E21-4533-A1F4-BD2158FD81ED}"/>
+                <a16:creationId xmlns:a16="http://schemas.microsoft.com/office/drawing/2014/main" id="{4A69E0A6-2288-497E-93C0-6186705555F2}"/>
               </a:ext>
             </a:extLst>
           </p:cNvPr>
@@ -5625,7 +5648,7 @@
           <p:cNvPr id="4" name="">
             <a:extLst xmlns:a="http://schemas.openxmlformats.org/drawingml/2006/main">
               <a:ext uri="{FF2B5EF4-FFF2-40B4-BE49-F238E27FC236}">
-                <a16:creationId xmlns:a16="http://schemas.microsoft.com/office/drawing/2014/main" id="{72B06688-8BD8-4D11-861E-BAB077F30C43}"/>
+                <a16:creationId xmlns:a16="http://schemas.microsoft.com/office/drawing/2014/main" id="{9067ECDB-E4B7-4C21-AFF4-31EC93727DDD}"/>
               </a:ext>
             </a:extLst>
           </p:cNvPr>
@@ -5682,7 +5705,7 @@
           <p:cNvPr id="5" name="">
             <a:extLst xmlns:a="http://schemas.openxmlformats.org/drawingml/2006/main">
               <a:ext uri="{FF2B5EF4-FFF2-40B4-BE49-F238E27FC236}">
-                <a16:creationId xmlns:a16="http://schemas.microsoft.com/office/drawing/2014/main" id="{2DA3AA32-75CD-4921-AFCD-A37B83942335}"/>
+                <a16:creationId xmlns:a16="http://schemas.microsoft.com/office/drawing/2014/main" id="{0885D7A0-2241-4773-B0B4-0E8F75B5925C}"/>
               </a:ext>
             </a:extLst>
           </p:cNvPr>
@@ -5762,36 +5785,36 @@
           <p:cNvPr id="6" name="">
             <a:extLst xmlns:a="http://schemas.openxmlformats.org/drawingml/2006/main">
               <a:ext uri="{FF2B5EF4-FFF2-40B4-BE49-F238E27FC236}">
-                <a16:creationId xmlns:a16="http://schemas.microsoft.com/office/drawing/2014/main" id="{04596131-0428-456F-B681-063C7770AF9D}"/>
-              </a:ext>
-            </a:extLst>
-          </p:cNvPr>
-          <p:cNvSpPr>
-            <a:spLocks xmlns:a="http://schemas.openxmlformats.org/drawingml/2006/main" noGrp="1"/>
-          </p:cNvSpPr>
-          <p:nvPr/>
-        </p:nvSpPr>
-        <p:spPr>
-          <a:xfrm xmlns:a="http://schemas.openxmlformats.org/drawingml/2006/main">
-            <a:off x="619125" y="5591175"/>
-            <a:ext cx="6191250" cy="723900"/>
-          </a:xfrm>
-          <a:prstGeom xmlns:a="http://schemas.openxmlformats.org/drawingml/2006/main" prst="rect">
-            <a:avLst/>
-          </a:prstGeom>
-          <a:noFill xmlns:a="http://schemas.openxmlformats.org/drawingml/2006/main"/>
-          <a:ln xmlns:a="http://schemas.openxmlformats.org/drawingml/2006/main" w="0">
-            <a:noFill/>
-          </a:ln>
-        </p:spPr>
-        <p:txBody>
-          <a:bodyPr xmlns:a="http://schemas.openxmlformats.org/drawingml/2006/main">
-            <a:noAutofit/>
-          </a:bodyPr>
-          <a:lstStyle xmlns:a="http://schemas.openxmlformats.org/drawingml/2006/main"/>
-          <a:p xmlns:a="http://schemas.openxmlformats.org/drawingml/2006/main">
-            <a:pPr>
-              <a:defRPr sz="4500" b="1">
+                <a16:creationId xmlns:a16="http://schemas.microsoft.com/office/drawing/2014/main" id="{B48CBFF7-D941-4A33-B60A-93AD08415094}"/>
+              </a:ext>
+            </a:extLst>
+          </p:cNvPr>
+          <p:cNvSpPr>
+            <a:spLocks xmlns:a="http://schemas.openxmlformats.org/drawingml/2006/main" noGrp="1"/>
+          </p:cNvSpPr>
+          <p:nvPr/>
+        </p:nvSpPr>
+        <p:spPr>
+          <a:xfrm xmlns:a="http://schemas.openxmlformats.org/drawingml/2006/main">
+            <a:off x="647700" y="5610225"/>
+            <a:ext cx="6705600" cy="504825"/>
+          </a:xfrm>
+          <a:prstGeom xmlns:a="http://schemas.openxmlformats.org/drawingml/2006/main" prst="rect">
+            <a:avLst/>
+          </a:prstGeom>
+          <a:noFill xmlns:a="http://schemas.openxmlformats.org/drawingml/2006/main"/>
+          <a:ln xmlns:a="http://schemas.openxmlformats.org/drawingml/2006/main" w="0">
+            <a:noFill/>
+          </a:ln>
+        </p:spPr>
+        <p:txBody>
+          <a:bodyPr xmlns:a="http://schemas.openxmlformats.org/drawingml/2006/main">
+            <a:noAutofit/>
+          </a:bodyPr>
+          <a:lstStyle xmlns:a="http://schemas.openxmlformats.org/drawingml/2006/main"/>
+          <a:p xmlns:a="http://schemas.openxmlformats.org/drawingml/2006/main">
+            <a:pPr>
+              <a:defRPr sz="2850" b="1">
                 <a:solidFill>
                   <a:srgbClr val="DDEC8B"/>
                 </a:solidFill>
@@ -5801,7 +5824,7 @@
               </a:defRPr>
             </a:pPr>
             <a:r>
-              <a:rPr sz="4500" b="1">
+              <a:rPr sz="2850" b="1">
                 <a:solidFill>
                   <a:srgbClr val="DDEC8B"/>
                 </a:solidFill>
@@ -5809,7 +5832,7 @@
                 <a:ea typeface="Helvetica Neue"/>
                 <a:cs typeface="Helvetica Neue"/>
               </a:rPr>
-              <a:t>Lotlight</a:t>
+              <a:t>lotlight-care.web.app</a:t>
             </a:r>
           </a:p>
         </p:txBody>
@@ -5819,7 +5842,64 @@
           <p:cNvPr id="7" name="">
             <a:extLst xmlns:a="http://schemas.openxmlformats.org/drawingml/2006/main">
               <a:ext uri="{FF2B5EF4-FFF2-40B4-BE49-F238E27FC236}">
-                <a16:creationId xmlns:a16="http://schemas.microsoft.com/office/drawing/2014/main" id="{B5B48779-9CD0-4C32-90BD-62543CD947FA}"/>
+                <a16:creationId xmlns:a16="http://schemas.microsoft.com/office/drawing/2014/main" id="{6C52DB82-C3E5-4AD9-BC36-1C6536DF332E}"/>
+              </a:ext>
+            </a:extLst>
+          </p:cNvPr>
+          <p:cNvSpPr>
+            <a:spLocks xmlns:a="http://schemas.openxmlformats.org/drawingml/2006/main" noGrp="1"/>
+          </p:cNvSpPr>
+          <p:nvPr/>
+        </p:nvSpPr>
+        <p:spPr>
+          <a:xfrm xmlns:a="http://schemas.openxmlformats.org/drawingml/2006/main">
+            <a:off x="647700" y="6191250"/>
+            <a:ext cx="6667500" cy="266700"/>
+          </a:xfrm>
+          <a:prstGeom xmlns:a="http://schemas.openxmlformats.org/drawingml/2006/main" prst="rect">
+            <a:avLst/>
+          </a:prstGeom>
+          <a:noFill xmlns:a="http://schemas.openxmlformats.org/drawingml/2006/main"/>
+          <a:ln xmlns:a="http://schemas.openxmlformats.org/drawingml/2006/main" w="0">
+            <a:noFill/>
+          </a:ln>
+        </p:spPr>
+        <p:txBody>
+          <a:bodyPr xmlns:a="http://schemas.openxmlformats.org/drawingml/2006/main">
+            <a:noAutofit/>
+          </a:bodyPr>
+          <a:lstStyle xmlns:a="http://schemas.openxmlformats.org/drawingml/2006/main"/>
+          <a:p xmlns:a="http://schemas.openxmlformats.org/drawingml/2006/main">
+            <a:pPr>
+              <a:defRPr sz="1500" b="0">
+                <a:solidFill>
+                  <a:srgbClr val="D7DFD0"/>
+                </a:solidFill>
+                <a:latin typeface="Helvetica Neue"/>
+                <a:ea typeface="Helvetica Neue"/>
+                <a:cs typeface="Helvetica Neue"/>
+              </a:defRPr>
+            </a:pPr>
+            <a:r>
+              <a:rPr sz="1500" b="0">
+                <a:solidFill>
+                  <a:srgbClr val="D7DFD0"/>
+                </a:solidFill>
+                <a:latin typeface="Helvetica Neue"/>
+                <a:ea typeface="Helvetica Neue"/>
+                <a:cs typeface="Helvetica Neue"/>
+              </a:rPr>
+              <a:t>169-second AI-narrated demo with captions</a:t>
+            </a:r>
+          </a:p>
+        </p:txBody>
+      </p:sp>
+      <p:sp>
+        <p:nvSpPr>
+          <p:cNvPr id="8" name="">
+            <a:extLst xmlns:a="http://schemas.openxmlformats.org/drawingml/2006/main">
+              <a:ext uri="{FF2B5EF4-FFF2-40B4-BE49-F238E27FC236}">
+                <a16:creationId xmlns:a16="http://schemas.microsoft.com/office/drawing/2014/main" id="{3B6B0722-788B-46A4-9DF1-55616E2B0C6D}"/>
               </a:ext>
             </a:extLst>
           </p:cNvPr>
@@ -5897,7 +5977,7 @@
     </p:spTree>
     <p:extLst>
       <p:ext uri="{BB962C8B-B14F-4D97-AF65-F5344CB8AC3E}">
-        <p14:creationId xmlns:p14="http://schemas.microsoft.com/office/powerpoint/2010/main" val="1277881350"/>
+        <p14:creationId xmlns:p14="http://schemas.microsoft.com/office/powerpoint/2010/main" val="222805706"/>
       </p:ext>
     </p:extLst>
   </p:cSld>

</xml_diff>

<commit_message>
Finalize public demo resources and submission release record
</commit_message>
<xml_diff>
--- a/submission/Lotlight-Pitch.pptx
+++ b/submission/Lotlight-Pitch.pptx
@@ -2,19 +2,19 @@
 <file path=ppt/presentation.xml><?xml version="1.0" encoding="utf-8"?>
 <p:presentation xmlns:p="http://schemas.openxmlformats.org/presentationml/2006/main">
   <p:sldMasterIdLst>
-    <p:sldMasterId xmlns:r="http://schemas.openxmlformats.org/officeDocument/2006/relationships" id="2147483648" r:id="R0a59fc1ea4dc4e1b"/>
+    <p:sldMasterId xmlns:r="http://schemas.openxmlformats.org/officeDocument/2006/relationships" id="2147483648" r:id="Rc4a3a74b4e9149ae"/>
   </p:sldMasterIdLst>
   <p:notesMasterIdLst>
-    <p:notesMasterId xmlns:r="http://schemas.openxmlformats.org/officeDocument/2006/relationships" r:id="R9b060e064da4416b"/>
+    <p:notesMasterId xmlns:r="http://schemas.openxmlformats.org/officeDocument/2006/relationships" r:id="R8b7de2ab8fe2497a"/>
   </p:notesMasterIdLst>
   <p:sldIdLst>
-    <p:sldId xmlns:r="http://schemas.openxmlformats.org/officeDocument/2006/relationships" id="256" r:id="R7b430f64ca214ab1"/>
-    <p:sldId xmlns:r="http://schemas.openxmlformats.org/officeDocument/2006/relationships" id="257" r:id="R89a7ea3d8dc94a5c"/>
-    <p:sldId xmlns:r="http://schemas.openxmlformats.org/officeDocument/2006/relationships" id="258" r:id="R4d26547b528b4664"/>
-    <p:sldId xmlns:r="http://schemas.openxmlformats.org/officeDocument/2006/relationships" id="259" r:id="R7eb18993fa66412e"/>
-    <p:sldId xmlns:r="http://schemas.openxmlformats.org/officeDocument/2006/relationships" id="260" r:id="R9d0308dfff0444ff"/>
-    <p:sldId xmlns:r="http://schemas.openxmlformats.org/officeDocument/2006/relationships" id="261" r:id="Ra3a6f11b375b4210"/>
-    <p:sldId xmlns:r="http://schemas.openxmlformats.org/officeDocument/2006/relationships" id="262" r:id="R85ef224d1d564a5f"/>
+    <p:sldId xmlns:r="http://schemas.openxmlformats.org/officeDocument/2006/relationships" id="256" r:id="R187ad6ea93da4ced"/>
+    <p:sldId xmlns:r="http://schemas.openxmlformats.org/officeDocument/2006/relationships" id="257" r:id="Rc30aac6b9f0342fc"/>
+    <p:sldId xmlns:r="http://schemas.openxmlformats.org/officeDocument/2006/relationships" id="258" r:id="Rc5f4d9ab8c974ae5"/>
+    <p:sldId xmlns:r="http://schemas.openxmlformats.org/officeDocument/2006/relationships" id="259" r:id="Rf95a098496854c96"/>
+    <p:sldId xmlns:r="http://schemas.openxmlformats.org/officeDocument/2006/relationships" id="260" r:id="R32dceacf8b4a460a"/>
+    <p:sldId xmlns:r="http://schemas.openxmlformats.org/officeDocument/2006/relationships" id="261" r:id="Rdff5fa3ec86243fa"/>
+    <p:sldId xmlns:r="http://schemas.openxmlformats.org/officeDocument/2006/relationships" id="262" r:id="R85db4c3e6a5e4fa2"/>
   </p:sldIdLst>
   <p:sldSz cx="12192000" cy="6858000"/>
   <p:notesSz cx="6858000" cy="9144000"/>
@@ -863,7 +863,7 @@
           <a:lstStyle xmlns:a="http://schemas.openxmlformats.org/drawingml/2006/main"/>
           <a:p xmlns:a="http://schemas.openxmlformats.org/drawingml/2006/main">
             <a:r>
-              <a:t>Thirty-six automated unit tests pass. Ten public Firebase browser tests pass, covering the review workflow, sign-in and persistence, exports and mobile use. We also ran real local AI inference on twelve hand-authored synthetic descriptions, with six relevant examples. The top six semantic results contained five of the relevant examples. Lexical matching found four. With a threshold of 0.3 chosen after inspecting this tiny set, the system surfaced five relevant candidates and no negative examples. It still missed one plausible alias. This is a smoke test and demonstration, not a held-out benchmark or a statistical accuracy claim. There are no real users or clinical validation yet. The next step is a supervised drill with clinic staff.</a:t>
+              <a:t>Thirty-six automated unit tests pass. Twelve public Firebase browser tests pass, covering the review workflow, sign-in and persistence, exports and mobile use, plus configuration failure recovery and deleted-account token denial. We also ran real local AI inference on twelve hand-authored synthetic descriptions, with six relevant examples. The top six semantic results contained five of the relevant examples. Lexical matching found four. With a threshold of 0.3 chosen after inspecting this tiny set, the system surfaced five relevant candidates and no negative examples. It still missed one plausible alias. This is a smoke test and demonstration, not a held-out benchmark or a statistical accuracy claim. There are no real users or clinical validation yet. The next step is a supervised drill with clinic staff.</a:t>
             </a:r>
           </a:p>
           <a:p xmlns:a="http://schemas.openxmlformats.org/drawingml/2006/main">
@@ -1021,7 +1021,7 @@
   </p:cSld>
   <p:clrMap bg1="lt1" tx1="dk1" bg2="lt2" tx2="dk2" accent1="accent1" accent2="accent2" accent3="accent3" accent4="accent4" accent5="accent5" accent6="accent6" hlink="hlink" folHlink="folHlink"/>
   <p:sldLayoutIdLst>
-    <p:sldLayoutId xmlns:r="http://schemas.openxmlformats.org/officeDocument/2006/relationships" id="2147483649" r:id="R9c3ac9a9e885448b"/>
+    <p:sldLayoutId xmlns:r="http://schemas.openxmlformats.org/officeDocument/2006/relationships" id="2147483649" r:id="Rbecfee12976d4b38"/>
   </p:sldLayoutIdLst>
   <p:txStyles>
     <p:titleStyle>
@@ -1572,7 +1572,7 @@
           <p:cNvPr id="9" name="">
             <a:extLst xmlns:a="http://schemas.openxmlformats.org/drawingml/2006/main">
               <a:ext uri="{FF2B5EF4-FFF2-40B4-BE49-F238E27FC236}">
-                <a16:creationId xmlns:a16="http://schemas.microsoft.com/office/drawing/2014/main" id="{EC9A1FFD-47C0-4E34-9648-5E2FAC10F018}"/>
+                <a16:creationId xmlns:a16="http://schemas.microsoft.com/office/drawing/2014/main" id="{9035BDC0-CC15-48D9-A804-6CF5BB93CE79}"/>
               </a:ext>
             </a:extLst>
           </p:cNvPr>
@@ -1629,7 +1629,7 @@
           <p:cNvPr id="2" name="">
             <a:extLst xmlns:a="http://schemas.openxmlformats.org/drawingml/2006/main">
               <a:ext uri="{FF2B5EF4-FFF2-40B4-BE49-F238E27FC236}">
-                <a16:creationId xmlns:a16="http://schemas.microsoft.com/office/drawing/2014/main" id="{B6C3B23E-A577-4B3B-8CFD-8AD46EDD809A}"/>
+                <a16:creationId xmlns:a16="http://schemas.microsoft.com/office/drawing/2014/main" id="{71A83C70-0398-445C-A390-8FCD825A8B08}"/>
               </a:ext>
             </a:extLst>
           </p:cNvPr>
@@ -1686,7 +1686,7 @@
           <p:cNvPr id="3" name="">
             <a:extLst xmlns:a="http://schemas.openxmlformats.org/drawingml/2006/main">
               <a:ext uri="{FF2B5EF4-FFF2-40B4-BE49-F238E27FC236}">
-                <a16:creationId xmlns:a16="http://schemas.microsoft.com/office/drawing/2014/main" id="{56D5B81A-72DB-4E56-8435-425A926AF484}"/>
+                <a16:creationId xmlns:a16="http://schemas.microsoft.com/office/drawing/2014/main" id="{5B9A32B8-59AF-43D8-81C2-E1A3A697EBC6}"/>
               </a:ext>
             </a:extLst>
           </p:cNvPr>
@@ -1766,7 +1766,7 @@
           <p:cNvPr id="4" name="">
             <a:extLst xmlns:a="http://schemas.openxmlformats.org/drawingml/2006/main">
               <a:ext uri="{FF2B5EF4-FFF2-40B4-BE49-F238E27FC236}">
-                <a16:creationId xmlns:a16="http://schemas.microsoft.com/office/drawing/2014/main" id="{F0098A41-0605-45CC-B31B-6B377D08A753}"/>
+                <a16:creationId xmlns:a16="http://schemas.microsoft.com/office/drawing/2014/main" id="{9442723A-879C-4007-B219-C4F86A03ABDE}"/>
               </a:ext>
             </a:extLst>
           </p:cNvPr>
@@ -1823,7 +1823,7 @@
           <p:cNvPr id="5" name="">
             <a:extLst xmlns:a="http://schemas.openxmlformats.org/drawingml/2006/main">
               <a:ext uri="{FF2B5EF4-FFF2-40B4-BE49-F238E27FC236}">
-                <a16:creationId xmlns:a16="http://schemas.microsoft.com/office/drawing/2014/main" id="{7F0101D1-F4E2-47CE-AB59-69A4A98EB2F3}"/>
+                <a16:creationId xmlns:a16="http://schemas.microsoft.com/office/drawing/2014/main" id="{8AE371CB-06CF-494F-9DB1-104504D61FA6}"/>
               </a:ext>
             </a:extLst>
           </p:cNvPr>
@@ -1880,7 +1880,7 @@
           <p:cNvPr id="6" name="">
             <a:extLst xmlns:a="http://schemas.openxmlformats.org/drawingml/2006/main">
               <a:ext uri="{FF2B5EF4-FFF2-40B4-BE49-F238E27FC236}">
-                <a16:creationId xmlns:a16="http://schemas.microsoft.com/office/drawing/2014/main" id="{9D9BBCF0-05A4-4738-B97A-34E9AA07185E}"/>
+                <a16:creationId xmlns:a16="http://schemas.microsoft.com/office/drawing/2014/main" id="{3987DBD6-7DD2-467B-AB29-D144C4DD6007}"/>
               </a:ext>
             </a:extLst>
           </p:cNvPr>
@@ -1960,7 +1960,7 @@
           <p:cNvPr id="7" name="">
             <a:extLst xmlns:a="http://schemas.openxmlformats.org/drawingml/2006/main">
               <a:ext uri="{FF2B5EF4-FFF2-40B4-BE49-F238E27FC236}">
-                <a16:creationId xmlns:a16="http://schemas.microsoft.com/office/drawing/2014/main" id="{D22C672C-64A6-4A6D-B086-3FC7A523A439}"/>
+                <a16:creationId xmlns:a16="http://schemas.microsoft.com/office/drawing/2014/main" id="{7BB79202-FEA7-40F8-A219-15B542BC7798}"/>
               </a:ext>
             </a:extLst>
           </p:cNvPr>
@@ -2017,7 +2017,7 @@
           <p:cNvPr id="8" name="">
             <a:extLst xmlns:a="http://schemas.openxmlformats.org/drawingml/2006/main">
               <a:ext uri="{FF2B5EF4-FFF2-40B4-BE49-F238E27FC236}">
-                <a16:creationId xmlns:a16="http://schemas.microsoft.com/office/drawing/2014/main" id="{BF6BD2E6-1791-4D92-A4F0-DD395FF8990C}"/>
+                <a16:creationId xmlns:a16="http://schemas.microsoft.com/office/drawing/2014/main" id="{82C252AB-74FA-4F91-969C-13A36F501E59}"/>
               </a:ext>
             </a:extLst>
           </p:cNvPr>
@@ -2072,7 +2072,7 @@
     </p:spTree>
     <p:extLst>
       <p:ext uri="{BB962C8B-B14F-4D97-AF65-F5344CB8AC3E}">
-        <p14:creationId xmlns:p14="http://schemas.microsoft.com/office/powerpoint/2010/main" val="686298574"/>
+        <p14:creationId xmlns:p14="http://schemas.microsoft.com/office/powerpoint/2010/main" val="1898238350"/>
       </p:ext>
     </p:extLst>
   </p:cSld>
@@ -2103,7 +2103,7 @@
           <p:cNvPr id="10" name="">
             <a:extLst xmlns:a="http://schemas.openxmlformats.org/drawingml/2006/main">
               <a:ext uri="{FF2B5EF4-FFF2-40B4-BE49-F238E27FC236}">
-                <a16:creationId xmlns:a16="http://schemas.microsoft.com/office/drawing/2014/main" id="{86873D14-849D-428F-96C8-B5E68E22EB31}"/>
+                <a16:creationId xmlns:a16="http://schemas.microsoft.com/office/drawing/2014/main" id="{C9C6DBCD-1EF8-48A1-9E48-5FEFA31E17BF}"/>
               </a:ext>
             </a:extLst>
           </p:cNvPr>
@@ -2160,7 +2160,7 @@
           <p:cNvPr id="2" name="">
             <a:extLst xmlns:a="http://schemas.openxmlformats.org/drawingml/2006/main">
               <a:ext uri="{FF2B5EF4-FFF2-40B4-BE49-F238E27FC236}">
-                <a16:creationId xmlns:a16="http://schemas.microsoft.com/office/drawing/2014/main" id="{551C2555-34FE-4AE3-88B8-223A72AD45F5}"/>
+                <a16:creationId xmlns:a16="http://schemas.microsoft.com/office/drawing/2014/main" id="{7CCD799E-4F28-40FE-BFF7-DBF97525DC39}"/>
               </a:ext>
             </a:extLst>
           </p:cNvPr>
@@ -2217,7 +2217,7 @@
           <p:cNvPr id="3" name="">
             <a:extLst xmlns:a="http://schemas.openxmlformats.org/drawingml/2006/main">
               <a:ext uri="{FF2B5EF4-FFF2-40B4-BE49-F238E27FC236}">
-                <a16:creationId xmlns:a16="http://schemas.microsoft.com/office/drawing/2014/main" id="{9EC1E676-4CF0-472D-A42E-0937B16F3F93}"/>
+                <a16:creationId xmlns:a16="http://schemas.microsoft.com/office/drawing/2014/main" id="{68E88CDA-699A-44B9-B084-45660EB42D7B}"/>
               </a:ext>
             </a:extLst>
           </p:cNvPr>
@@ -2274,7 +2274,7 @@
           <p:cNvPr id="4" name="">
             <a:extLst xmlns:a="http://schemas.openxmlformats.org/drawingml/2006/main">
               <a:ext uri="{FF2B5EF4-FFF2-40B4-BE49-F238E27FC236}">
-                <a16:creationId xmlns:a16="http://schemas.microsoft.com/office/drawing/2014/main" id="{4F2B5D7F-10A5-40D0-9616-B791B6A944C1}"/>
+                <a16:creationId xmlns:a16="http://schemas.microsoft.com/office/drawing/2014/main" id="{FCAEBE6B-80D1-4FC1-8CC5-A9292FEAD714}"/>
               </a:ext>
             </a:extLst>
           </p:cNvPr>
@@ -2331,7 +2331,7 @@
           <p:cNvPr id="5" name="">
             <a:extLst xmlns:a="http://schemas.openxmlformats.org/drawingml/2006/main">
               <a:ext uri="{FF2B5EF4-FFF2-40B4-BE49-F238E27FC236}">
-                <a16:creationId xmlns:a16="http://schemas.microsoft.com/office/drawing/2014/main" id="{AD95EF11-392D-4AE1-AB1A-96CC9A8930A1}"/>
+                <a16:creationId xmlns:a16="http://schemas.microsoft.com/office/drawing/2014/main" id="{AAFF5BF1-C51B-47EE-A640-1FAE0D0000F3}"/>
               </a:ext>
             </a:extLst>
           </p:cNvPr>
@@ -2388,7 +2388,7 @@
           <p:cNvPr id="6" name="">
             <a:extLst xmlns:a="http://schemas.openxmlformats.org/drawingml/2006/main">
               <a:ext uri="{FF2B5EF4-FFF2-40B4-BE49-F238E27FC236}">
-                <a16:creationId xmlns:a16="http://schemas.microsoft.com/office/drawing/2014/main" id="{95B6454A-BA5B-4363-A316-75C411FC534A}"/>
+                <a16:creationId xmlns:a16="http://schemas.microsoft.com/office/drawing/2014/main" id="{F8B6B357-0623-4652-9984-CD36CD516316}"/>
               </a:ext>
             </a:extLst>
           </p:cNvPr>
@@ -2445,7 +2445,7 @@
           <p:cNvPr id="7" name="">
             <a:extLst xmlns:a="http://schemas.openxmlformats.org/drawingml/2006/main">
               <a:ext uri="{FF2B5EF4-FFF2-40B4-BE49-F238E27FC236}">
-                <a16:creationId xmlns:a16="http://schemas.microsoft.com/office/drawing/2014/main" id="{74366049-8665-4C7C-8D7C-FCFE6264A6EA}"/>
+                <a16:creationId xmlns:a16="http://schemas.microsoft.com/office/drawing/2014/main" id="{8DEE3354-7AAA-422F-9B87-1E1906BEB14C}"/>
               </a:ext>
             </a:extLst>
           </p:cNvPr>
@@ -2506,7 +2506,7 @@
           <p:nvPr/>
         </p:nvPicPr>
         <p:blipFill>
-          <a:blip xmlns:r="http://schemas.openxmlformats.org/officeDocument/2006/relationships" xmlns:a="http://schemas.openxmlformats.org/drawingml/2006/main" r:embed="R61c510d0016f4cac"/>
+          <a:blip xmlns:r="http://schemas.openxmlformats.org/officeDocument/2006/relationships" xmlns:a="http://schemas.openxmlformats.org/drawingml/2006/main" r:embed="Racd8d78d364b44ce"/>
           <a:stretch xmlns:a="http://schemas.openxmlformats.org/drawingml/2006/main"/>
         </p:blipFill>
         <p:spPr>
@@ -2524,7 +2524,7 @@
           <p:cNvPr id="9" name="">
             <a:extLst xmlns:a="http://schemas.openxmlformats.org/drawingml/2006/main">
               <a:ext uri="{FF2B5EF4-FFF2-40B4-BE49-F238E27FC236}">
-                <a16:creationId xmlns:a16="http://schemas.microsoft.com/office/drawing/2014/main" id="{E251F788-52A1-413C-AB13-CC8D3F8964A4}"/>
+                <a16:creationId xmlns:a16="http://schemas.microsoft.com/office/drawing/2014/main" id="{D08F0A77-DF3D-4CCC-A6A8-1D9EAF312D6C}"/>
               </a:ext>
             </a:extLst>
           </p:cNvPr>
@@ -2579,7 +2579,7 @@
     </p:spTree>
     <p:extLst>
       <p:ext uri="{BB962C8B-B14F-4D97-AF65-F5344CB8AC3E}">
-        <p14:creationId xmlns:p14="http://schemas.microsoft.com/office/powerpoint/2010/main" val="1045795931"/>
+        <p14:creationId xmlns:p14="http://schemas.microsoft.com/office/powerpoint/2010/main" val="1381425420"/>
       </p:ext>
     </p:extLst>
   </p:cSld>
@@ -2610,7 +2610,7 @@
           <p:cNvPr id="11" name="">
             <a:extLst xmlns:a="http://schemas.openxmlformats.org/drawingml/2006/main">
               <a:ext uri="{FF2B5EF4-FFF2-40B4-BE49-F238E27FC236}">
-                <a16:creationId xmlns:a16="http://schemas.microsoft.com/office/drawing/2014/main" id="{F77E82DB-C2D8-4A28-9C40-EC0E92587200}"/>
+                <a16:creationId xmlns:a16="http://schemas.microsoft.com/office/drawing/2014/main" id="{978D571A-39B0-4E33-ACB6-8217AFF7A752}"/>
               </a:ext>
             </a:extLst>
           </p:cNvPr>
@@ -2667,7 +2667,7 @@
           <p:cNvPr id="2" name="">
             <a:extLst xmlns:a="http://schemas.openxmlformats.org/drawingml/2006/main">
               <a:ext uri="{FF2B5EF4-FFF2-40B4-BE49-F238E27FC236}">
-                <a16:creationId xmlns:a16="http://schemas.microsoft.com/office/drawing/2014/main" id="{0383B63C-E5FF-4BF6-8047-DD7BA1DB34B2}"/>
+                <a16:creationId xmlns:a16="http://schemas.microsoft.com/office/drawing/2014/main" id="{9F85A805-A7E3-44FE-AA4D-3093ADEB3676}"/>
               </a:ext>
             </a:extLst>
           </p:cNvPr>
@@ -2724,7 +2724,7 @@
           <p:cNvPr id="3" name="">
             <a:extLst xmlns:a="http://schemas.openxmlformats.org/drawingml/2006/main">
               <a:ext uri="{FF2B5EF4-FFF2-40B4-BE49-F238E27FC236}">
-                <a16:creationId xmlns:a16="http://schemas.microsoft.com/office/drawing/2014/main" id="{7BF06086-295F-4E43-A2DB-224401C33AAA}"/>
+                <a16:creationId xmlns:a16="http://schemas.microsoft.com/office/drawing/2014/main" id="{5D186786-C522-4C0D-B4A4-68708EB05AE0}"/>
               </a:ext>
             </a:extLst>
           </p:cNvPr>
@@ -2781,7 +2781,7 @@
           <p:cNvPr id="4" name="">
             <a:extLst xmlns:a="http://schemas.openxmlformats.org/drawingml/2006/main">
               <a:ext uri="{FF2B5EF4-FFF2-40B4-BE49-F238E27FC236}">
-                <a16:creationId xmlns:a16="http://schemas.microsoft.com/office/drawing/2014/main" id="{6E485E9F-53E1-4B2B-97AE-B682FA2D7A09}"/>
+                <a16:creationId xmlns:a16="http://schemas.microsoft.com/office/drawing/2014/main" id="{3910DFF8-AF02-4B64-A0AC-657671331BA1}"/>
               </a:ext>
             </a:extLst>
           </p:cNvPr>
@@ -2838,7 +2838,7 @@
           <p:cNvPr id="5" name="">
             <a:extLst xmlns:a="http://schemas.openxmlformats.org/drawingml/2006/main">
               <a:ext uri="{FF2B5EF4-FFF2-40B4-BE49-F238E27FC236}">
-                <a16:creationId xmlns:a16="http://schemas.microsoft.com/office/drawing/2014/main" id="{53BF2438-DE60-4DE3-ABF3-3A0FE3EBB619}"/>
+                <a16:creationId xmlns:a16="http://schemas.microsoft.com/office/drawing/2014/main" id="{47E9317C-564A-4CCB-B559-1DA070722B3A}"/>
               </a:ext>
             </a:extLst>
           </p:cNvPr>
@@ -2918,7 +2918,7 @@
           <p:cNvPr id="6" name="">
             <a:extLst xmlns:a="http://schemas.openxmlformats.org/drawingml/2006/main">
               <a:ext uri="{FF2B5EF4-FFF2-40B4-BE49-F238E27FC236}">
-                <a16:creationId xmlns:a16="http://schemas.microsoft.com/office/drawing/2014/main" id="{32A8074E-38A6-4CDC-8880-EE49BD58794B}"/>
+                <a16:creationId xmlns:a16="http://schemas.microsoft.com/office/drawing/2014/main" id="{5BDF5179-498C-4CAE-AA05-29EAC0CC3C63}"/>
               </a:ext>
             </a:extLst>
           </p:cNvPr>
@@ -2975,7 +2975,7 @@
           <p:cNvPr id="7" name="">
             <a:extLst xmlns:a="http://schemas.openxmlformats.org/drawingml/2006/main">
               <a:ext uri="{FF2B5EF4-FFF2-40B4-BE49-F238E27FC236}">
-                <a16:creationId xmlns:a16="http://schemas.microsoft.com/office/drawing/2014/main" id="{4603B821-4C38-4E2B-90F4-187E2574DE4D}"/>
+                <a16:creationId xmlns:a16="http://schemas.microsoft.com/office/drawing/2014/main" id="{6C56B6A0-C35E-4520-BC51-945EB5C81F5D}"/>
               </a:ext>
             </a:extLst>
           </p:cNvPr>
@@ -3036,7 +3036,7 @@
           <p:nvPr/>
         </p:nvPicPr>
         <p:blipFill>
-          <a:blip xmlns:r="http://schemas.openxmlformats.org/officeDocument/2006/relationships" xmlns:a="http://schemas.openxmlformats.org/drawingml/2006/main" r:embed="R4193dc93bd0845c1"/>
+          <a:blip xmlns:r="http://schemas.openxmlformats.org/officeDocument/2006/relationships" xmlns:a="http://schemas.openxmlformats.org/drawingml/2006/main" r:embed="Reff04faedca0497f"/>
           <a:srcRect xmlns:a="http://schemas.openxmlformats.org/drawingml/2006/main" l="0" t="24705" r="0" b="24705"/>
           <a:stretch xmlns:a="http://schemas.openxmlformats.org/drawingml/2006/main">
             <a:fillRect l="0" t="0" r="0" b="0"/>
@@ -3057,7 +3057,7 @@
           <p:cNvPr id="9" name="">
             <a:extLst xmlns:a="http://schemas.openxmlformats.org/drawingml/2006/main">
               <a:ext uri="{FF2B5EF4-FFF2-40B4-BE49-F238E27FC236}">
-                <a16:creationId xmlns:a16="http://schemas.microsoft.com/office/drawing/2014/main" id="{EE5D1AC8-4DD0-432E-B6CB-6F7555714620}"/>
+                <a16:creationId xmlns:a16="http://schemas.microsoft.com/office/drawing/2014/main" id="{B971A990-2930-4519-BCD2-8E575A5EE8A8}"/>
               </a:ext>
             </a:extLst>
           </p:cNvPr>
@@ -3114,7 +3114,7 @@
           <p:cNvPr id="10" name="">
             <a:extLst xmlns:a="http://schemas.openxmlformats.org/drawingml/2006/main">
               <a:ext uri="{FF2B5EF4-FFF2-40B4-BE49-F238E27FC236}">
-                <a16:creationId xmlns:a16="http://schemas.microsoft.com/office/drawing/2014/main" id="{9DB883D0-ACEF-4420-B53E-F9B1E3991606}"/>
+                <a16:creationId xmlns:a16="http://schemas.microsoft.com/office/drawing/2014/main" id="{EC57D2AC-89BC-4EB2-B2B4-AE89CC108956}"/>
               </a:ext>
             </a:extLst>
           </p:cNvPr>
@@ -3169,7 +3169,7 @@
     </p:spTree>
     <p:extLst>
       <p:ext uri="{BB962C8B-B14F-4D97-AF65-F5344CB8AC3E}">
-        <p14:creationId xmlns:p14="http://schemas.microsoft.com/office/powerpoint/2010/main" val="50456875"/>
+        <p14:creationId xmlns:p14="http://schemas.microsoft.com/office/powerpoint/2010/main" val="267231577"/>
       </p:ext>
     </p:extLst>
   </p:cSld>
@@ -3200,7 +3200,7 @@
           <p:cNvPr id="17" name="">
             <a:extLst xmlns:a="http://schemas.openxmlformats.org/drawingml/2006/main">
               <a:ext uri="{FF2B5EF4-FFF2-40B4-BE49-F238E27FC236}">
-                <a16:creationId xmlns:a16="http://schemas.microsoft.com/office/drawing/2014/main" id="{222DFC20-456B-4CE3-A403-0F17DFFFA00B}"/>
+                <a16:creationId xmlns:a16="http://schemas.microsoft.com/office/drawing/2014/main" id="{C92A86C7-92B5-4A4F-9987-DB9BEB11F6CC}"/>
               </a:ext>
             </a:extLst>
           </p:cNvPr>
@@ -3257,7 +3257,7 @@
           <p:cNvPr id="2" name="">
             <a:extLst xmlns:a="http://schemas.openxmlformats.org/drawingml/2006/main">
               <a:ext uri="{FF2B5EF4-FFF2-40B4-BE49-F238E27FC236}">
-                <a16:creationId xmlns:a16="http://schemas.microsoft.com/office/drawing/2014/main" id="{222C5DFC-4668-40AC-8652-2FCE1C1ADA06}"/>
+                <a16:creationId xmlns:a16="http://schemas.microsoft.com/office/drawing/2014/main" id="{0A6C5BEB-8388-44C4-997A-FD815E9FACE8}"/>
               </a:ext>
             </a:extLst>
           </p:cNvPr>
@@ -3314,7 +3314,7 @@
           <p:cNvPr id="3" name="">
             <a:extLst xmlns:a="http://schemas.openxmlformats.org/drawingml/2006/main">
               <a:ext uri="{FF2B5EF4-FFF2-40B4-BE49-F238E27FC236}">
-                <a16:creationId xmlns:a16="http://schemas.microsoft.com/office/drawing/2014/main" id="{2E357A96-4ED4-4E90-AC0C-D02323EC0059}"/>
+                <a16:creationId xmlns:a16="http://schemas.microsoft.com/office/drawing/2014/main" id="{6CB49E4D-A11F-46B9-A3E4-D178B4D3508A}"/>
               </a:ext>
             </a:extLst>
           </p:cNvPr>
@@ -3371,7 +3371,7 @@
           <p:cNvPr id="4" name="">
             <a:extLst xmlns:a="http://schemas.openxmlformats.org/drawingml/2006/main">
               <a:ext uri="{FF2B5EF4-FFF2-40B4-BE49-F238E27FC236}">
-                <a16:creationId xmlns:a16="http://schemas.microsoft.com/office/drawing/2014/main" id="{D540A2F0-9745-441B-B2CE-D0DB0E83EEC4}"/>
+                <a16:creationId xmlns:a16="http://schemas.microsoft.com/office/drawing/2014/main" id="{4999E290-5D29-44D4-80DF-B1EFEC43D35D}"/>
               </a:ext>
             </a:extLst>
           </p:cNvPr>
@@ -3428,7 +3428,7 @@
           <p:cNvPr id="5" name="">
             <a:extLst xmlns:a="http://schemas.openxmlformats.org/drawingml/2006/main">
               <a:ext uri="{FF2B5EF4-FFF2-40B4-BE49-F238E27FC236}">
-                <a16:creationId xmlns:a16="http://schemas.microsoft.com/office/drawing/2014/main" id="{0C52AADB-964A-42DB-956C-A8B25A49D419}"/>
+                <a16:creationId xmlns:a16="http://schemas.microsoft.com/office/drawing/2014/main" id="{72A01ED4-0932-493A-AA6D-BD865CBE5D15}"/>
               </a:ext>
             </a:extLst>
           </p:cNvPr>
@@ -3485,7 +3485,7 @@
           <p:cNvPr id="6" name="">
             <a:extLst xmlns:a="http://schemas.openxmlformats.org/drawingml/2006/main">
               <a:ext uri="{FF2B5EF4-FFF2-40B4-BE49-F238E27FC236}">
-                <a16:creationId xmlns:a16="http://schemas.microsoft.com/office/drawing/2014/main" id="{2EA28D64-AB3F-4466-A0EA-6FE7D20798B8}"/>
+                <a16:creationId xmlns:a16="http://schemas.microsoft.com/office/drawing/2014/main" id="{006EE41B-F18C-4317-AE08-F309E4528846}"/>
               </a:ext>
             </a:extLst>
           </p:cNvPr>
@@ -3542,7 +3542,7 @@
           <p:cNvPr id="7" name="">
             <a:extLst xmlns:a="http://schemas.openxmlformats.org/drawingml/2006/main">
               <a:ext uri="{FF2B5EF4-FFF2-40B4-BE49-F238E27FC236}">
-                <a16:creationId xmlns:a16="http://schemas.microsoft.com/office/drawing/2014/main" id="{91A24D90-9509-495C-AD9A-03925A00BF49}"/>
+                <a16:creationId xmlns:a16="http://schemas.microsoft.com/office/drawing/2014/main" id="{5C03D3E3-0176-427E-99D0-4EAC02D5A794}"/>
               </a:ext>
             </a:extLst>
           </p:cNvPr>
@@ -3599,7 +3599,7 @@
           <p:cNvPr id="8" name="">
             <a:extLst xmlns:a="http://schemas.openxmlformats.org/drawingml/2006/main">
               <a:ext uri="{FF2B5EF4-FFF2-40B4-BE49-F238E27FC236}">
-                <a16:creationId xmlns:a16="http://schemas.microsoft.com/office/drawing/2014/main" id="{674BD8EE-F172-44E1-95C2-8E2E978A4966}"/>
+                <a16:creationId xmlns:a16="http://schemas.microsoft.com/office/drawing/2014/main" id="{C31768EB-E191-438F-8EDF-142324CDB925}"/>
               </a:ext>
             </a:extLst>
           </p:cNvPr>
@@ -3656,7 +3656,7 @@
           <p:cNvPr id="9" name="">
             <a:extLst xmlns:a="http://schemas.openxmlformats.org/drawingml/2006/main">
               <a:ext uri="{FF2B5EF4-FFF2-40B4-BE49-F238E27FC236}">
-                <a16:creationId xmlns:a16="http://schemas.microsoft.com/office/drawing/2014/main" id="{4CCDD923-9794-47CF-8B9D-7496C4EE3FF5}"/>
+                <a16:creationId xmlns:a16="http://schemas.microsoft.com/office/drawing/2014/main" id="{F2A5A01A-BF01-49FE-BB3B-81B93220580E}"/>
               </a:ext>
             </a:extLst>
           </p:cNvPr>
@@ -3713,7 +3713,7 @@
           <p:cNvPr id="10" name="">
             <a:extLst xmlns:a="http://schemas.openxmlformats.org/drawingml/2006/main">
               <a:ext uri="{FF2B5EF4-FFF2-40B4-BE49-F238E27FC236}">
-                <a16:creationId xmlns:a16="http://schemas.microsoft.com/office/drawing/2014/main" id="{2E66842E-B196-42DC-888E-9DF702AFCFEF}"/>
+                <a16:creationId xmlns:a16="http://schemas.microsoft.com/office/drawing/2014/main" id="{8100DF44-123A-4507-834A-B85975D175A9}"/>
               </a:ext>
             </a:extLst>
           </p:cNvPr>
@@ -3770,7 +3770,7 @@
           <p:cNvPr id="11" name="">
             <a:extLst xmlns:a="http://schemas.openxmlformats.org/drawingml/2006/main">
               <a:ext uri="{FF2B5EF4-FFF2-40B4-BE49-F238E27FC236}">
-                <a16:creationId xmlns:a16="http://schemas.microsoft.com/office/drawing/2014/main" id="{34639559-3A1B-4DB4-A983-4CC2CF770F75}"/>
+                <a16:creationId xmlns:a16="http://schemas.microsoft.com/office/drawing/2014/main" id="{16A2AC98-DDEA-4F72-B002-0CC4AC800A5E}"/>
               </a:ext>
             </a:extLst>
           </p:cNvPr>
@@ -3827,7 +3827,7 @@
           <p:cNvPr id="12" name="">
             <a:extLst xmlns:a="http://schemas.openxmlformats.org/drawingml/2006/main">
               <a:ext uri="{FF2B5EF4-FFF2-40B4-BE49-F238E27FC236}">
-                <a16:creationId xmlns:a16="http://schemas.microsoft.com/office/drawing/2014/main" id="{2673A4F9-D2C6-4772-8384-D5A790DC22F8}"/>
+                <a16:creationId xmlns:a16="http://schemas.microsoft.com/office/drawing/2014/main" id="{3E2A0E6C-50FA-48F5-AE4D-0AA82AF242DE}"/>
               </a:ext>
             </a:extLst>
           </p:cNvPr>
@@ -3884,7 +3884,7 @@
           <p:cNvPr id="13" name="">
             <a:extLst xmlns:a="http://schemas.openxmlformats.org/drawingml/2006/main">
               <a:ext uri="{FF2B5EF4-FFF2-40B4-BE49-F238E27FC236}">
-                <a16:creationId xmlns:a16="http://schemas.microsoft.com/office/drawing/2014/main" id="{6533596A-CF73-44AB-8E7C-EECDA48EE222}"/>
+                <a16:creationId xmlns:a16="http://schemas.microsoft.com/office/drawing/2014/main" id="{12E1C74B-E7AE-42DB-A4E5-C2F5CF6E0A6B}"/>
               </a:ext>
             </a:extLst>
           </p:cNvPr>
@@ -3941,7 +3941,7 @@
           <p:cNvPr id="14" name="">
             <a:extLst xmlns:a="http://schemas.openxmlformats.org/drawingml/2006/main">
               <a:ext uri="{FF2B5EF4-FFF2-40B4-BE49-F238E27FC236}">
-                <a16:creationId xmlns:a16="http://schemas.microsoft.com/office/drawing/2014/main" id="{516DBD94-B592-4163-8F70-77C1AEF949A2}"/>
+                <a16:creationId xmlns:a16="http://schemas.microsoft.com/office/drawing/2014/main" id="{3F59622B-EEE8-4A7D-8CD6-AAB201C14D8C}"/>
               </a:ext>
             </a:extLst>
           </p:cNvPr>
@@ -3998,7 +3998,7 @@
           <p:cNvPr id="15" name="">
             <a:extLst xmlns:a="http://schemas.openxmlformats.org/drawingml/2006/main">
               <a:ext uri="{FF2B5EF4-FFF2-40B4-BE49-F238E27FC236}">
-                <a16:creationId xmlns:a16="http://schemas.microsoft.com/office/drawing/2014/main" id="{5650FE12-ABC4-4294-A300-00B5D0E723B3}"/>
+                <a16:creationId xmlns:a16="http://schemas.microsoft.com/office/drawing/2014/main" id="{1071045D-FFDF-4F0D-8D55-54AD6A73F129}"/>
               </a:ext>
             </a:extLst>
           </p:cNvPr>
@@ -4055,7 +4055,7 @@
           <p:cNvPr id="16" name="">
             <a:extLst xmlns:a="http://schemas.openxmlformats.org/drawingml/2006/main">
               <a:ext uri="{FF2B5EF4-FFF2-40B4-BE49-F238E27FC236}">
-                <a16:creationId xmlns:a16="http://schemas.microsoft.com/office/drawing/2014/main" id="{97929EBE-612A-4991-B845-7E8B848D6BD3}"/>
+                <a16:creationId xmlns:a16="http://schemas.microsoft.com/office/drawing/2014/main" id="{8F3789A2-4097-4918-9680-CE35E1D4D6AF}"/>
               </a:ext>
             </a:extLst>
           </p:cNvPr>
@@ -4133,7 +4133,7 @@
     </p:spTree>
     <p:extLst>
       <p:ext uri="{BB962C8B-B14F-4D97-AF65-F5344CB8AC3E}">
-        <p14:creationId xmlns:p14="http://schemas.microsoft.com/office/powerpoint/2010/main" val="11393659"/>
+        <p14:creationId xmlns:p14="http://schemas.microsoft.com/office/powerpoint/2010/main" val="1417797137"/>
       </p:ext>
     </p:extLst>
   </p:cSld>
@@ -4164,7 +4164,7 @@
           <p:cNvPr id="11" name="">
             <a:extLst xmlns:a="http://schemas.openxmlformats.org/drawingml/2006/main">
               <a:ext uri="{FF2B5EF4-FFF2-40B4-BE49-F238E27FC236}">
-                <a16:creationId xmlns:a16="http://schemas.microsoft.com/office/drawing/2014/main" id="{22861BA4-D924-4138-9889-2A5F63D9A6FA}"/>
+                <a16:creationId xmlns:a16="http://schemas.microsoft.com/office/drawing/2014/main" id="{6E8D6098-CA07-479B-B9D1-D290748C427B}"/>
               </a:ext>
             </a:extLst>
           </p:cNvPr>
@@ -4221,7 +4221,7 @@
           <p:cNvPr id="2" name="">
             <a:extLst xmlns:a="http://schemas.openxmlformats.org/drawingml/2006/main">
               <a:ext uri="{FF2B5EF4-FFF2-40B4-BE49-F238E27FC236}">
-                <a16:creationId xmlns:a16="http://schemas.microsoft.com/office/drawing/2014/main" id="{8AD5F327-0C03-4A32-9720-D72149841B60}"/>
+                <a16:creationId xmlns:a16="http://schemas.microsoft.com/office/drawing/2014/main" id="{860348D5-5B2F-427C-8E04-2E37EE49E4A2}"/>
               </a:ext>
             </a:extLst>
           </p:cNvPr>
@@ -4278,7 +4278,7 @@
           <p:cNvPr id="3" name="">
             <a:extLst xmlns:a="http://schemas.openxmlformats.org/drawingml/2006/main">
               <a:ext uri="{FF2B5EF4-FFF2-40B4-BE49-F238E27FC236}">
-                <a16:creationId xmlns:a16="http://schemas.microsoft.com/office/drawing/2014/main" id="{7C56DD96-76D3-4466-9CF8-EBACEAC6B98F}"/>
+                <a16:creationId xmlns:a16="http://schemas.microsoft.com/office/drawing/2014/main" id="{B5565030-AF80-4BF8-9589-BF5B468C35EA}"/>
               </a:ext>
             </a:extLst>
           </p:cNvPr>
@@ -4335,7 +4335,7 @@
           <p:cNvPr id="4" name="">
             <a:extLst xmlns:a="http://schemas.openxmlformats.org/drawingml/2006/main">
               <a:ext uri="{FF2B5EF4-FFF2-40B4-BE49-F238E27FC236}">
-                <a16:creationId xmlns:a16="http://schemas.microsoft.com/office/drawing/2014/main" id="{B9C743F7-AEB4-4206-B616-DB0724B71073}"/>
+                <a16:creationId xmlns:a16="http://schemas.microsoft.com/office/drawing/2014/main" id="{136F0B2D-AE33-415B-8E79-39D9D5079ECC}"/>
               </a:ext>
             </a:extLst>
           </p:cNvPr>
@@ -4392,7 +4392,7 @@
           <p:cNvPr id="5" name="">
             <a:extLst xmlns:a="http://schemas.openxmlformats.org/drawingml/2006/main">
               <a:ext uri="{FF2B5EF4-FFF2-40B4-BE49-F238E27FC236}">
-                <a16:creationId xmlns:a16="http://schemas.microsoft.com/office/drawing/2014/main" id="{CDC3D1DE-7223-498F-8614-5F6B76A630C1}"/>
+                <a16:creationId xmlns:a16="http://schemas.microsoft.com/office/drawing/2014/main" id="{1CA69819-3C59-4C0C-B972-FD384DF88E2D}"/>
               </a:ext>
             </a:extLst>
           </p:cNvPr>
@@ -4449,7 +4449,7 @@
           <p:cNvPr id="6" name="">
             <a:extLst xmlns:a="http://schemas.openxmlformats.org/drawingml/2006/main">
               <a:ext uri="{FF2B5EF4-FFF2-40B4-BE49-F238E27FC236}">
-                <a16:creationId xmlns:a16="http://schemas.microsoft.com/office/drawing/2014/main" id="{9EAFC12B-F7DC-42A4-86FB-836256084FBB}"/>
+                <a16:creationId xmlns:a16="http://schemas.microsoft.com/office/drawing/2014/main" id="{9CF2E1BC-A709-40CC-B579-C3319DC706F2}"/>
               </a:ext>
             </a:extLst>
           </p:cNvPr>
@@ -4506,7 +4506,7 @@
           <p:cNvPr id="7" name="">
             <a:extLst xmlns:a="http://schemas.openxmlformats.org/drawingml/2006/main">
               <a:ext uri="{FF2B5EF4-FFF2-40B4-BE49-F238E27FC236}">
-                <a16:creationId xmlns:a16="http://schemas.microsoft.com/office/drawing/2014/main" id="{77E96EFE-4556-41DD-AAAB-F746FAF3D5D8}"/>
+                <a16:creationId xmlns:a16="http://schemas.microsoft.com/office/drawing/2014/main" id="{E6752502-8490-4F9A-9B88-61E06F00E2DA}"/>
               </a:ext>
             </a:extLst>
           </p:cNvPr>
@@ -4563,7 +4563,7 @@
           <p:cNvPr id="8" name="">
             <a:extLst xmlns:a="http://schemas.openxmlformats.org/drawingml/2006/main">
               <a:ext uri="{FF2B5EF4-FFF2-40B4-BE49-F238E27FC236}">
-                <a16:creationId xmlns:a16="http://schemas.microsoft.com/office/drawing/2014/main" id="{52B800AD-590A-4700-9F9C-FD3B4BC420CA}"/>
+                <a16:creationId xmlns:a16="http://schemas.microsoft.com/office/drawing/2014/main" id="{ED1F6C27-D6E8-4E15-9913-F34E6CF11C47}"/>
               </a:ext>
             </a:extLst>
           </p:cNvPr>
@@ -4643,7 +4643,7 @@
           <p:cNvPr id="9" name="">
             <a:extLst xmlns:a="http://schemas.openxmlformats.org/drawingml/2006/main">
               <a:ext uri="{FF2B5EF4-FFF2-40B4-BE49-F238E27FC236}">
-                <a16:creationId xmlns:a16="http://schemas.microsoft.com/office/drawing/2014/main" id="{9E073C1A-FAE2-41CE-ACBF-CEBBF1C3073F}"/>
+                <a16:creationId xmlns:a16="http://schemas.microsoft.com/office/drawing/2014/main" id="{C504D74F-98CA-458A-A5AB-AD8D178AFF1B}"/>
               </a:ext>
             </a:extLst>
           </p:cNvPr>
@@ -4700,7 +4700,7 @@
           <p:cNvPr id="10" name="">
             <a:extLst xmlns:a="http://schemas.openxmlformats.org/drawingml/2006/main">
               <a:ext uri="{FF2B5EF4-FFF2-40B4-BE49-F238E27FC236}">
-                <a16:creationId xmlns:a16="http://schemas.microsoft.com/office/drawing/2014/main" id="{8121C824-1048-45BF-8AF5-67C5D2B008CE}"/>
+                <a16:creationId xmlns:a16="http://schemas.microsoft.com/office/drawing/2014/main" id="{48A2CEE5-CE60-40CF-A202-2D2556BAB520}"/>
               </a:ext>
             </a:extLst>
           </p:cNvPr>
@@ -4778,7 +4778,7 @@
     </p:spTree>
     <p:extLst>
       <p:ext uri="{BB962C8B-B14F-4D97-AF65-F5344CB8AC3E}">
-        <p14:creationId xmlns:p14="http://schemas.microsoft.com/office/powerpoint/2010/main" val="399749672"/>
+        <p14:creationId xmlns:p14="http://schemas.microsoft.com/office/powerpoint/2010/main" val="825328596"/>
       </p:ext>
     </p:extLst>
   </p:cSld>
@@ -4809,7 +4809,7 @@
           <p:cNvPr id="11" name="">
             <a:extLst xmlns:a="http://schemas.openxmlformats.org/drawingml/2006/main">
               <a:ext uri="{FF2B5EF4-FFF2-40B4-BE49-F238E27FC236}">
-                <a16:creationId xmlns:a16="http://schemas.microsoft.com/office/drawing/2014/main" id="{B491E99F-6DD6-4F2C-9BFE-2742871B1976}"/>
+                <a16:creationId xmlns:a16="http://schemas.microsoft.com/office/drawing/2014/main" id="{278779B8-ED18-4DC9-8F04-91FC3878FEA9}"/>
               </a:ext>
             </a:extLst>
           </p:cNvPr>
@@ -4866,7 +4866,7 @@
           <p:cNvPr id="2" name="">
             <a:extLst xmlns:a="http://schemas.openxmlformats.org/drawingml/2006/main">
               <a:ext uri="{FF2B5EF4-FFF2-40B4-BE49-F238E27FC236}">
-                <a16:creationId xmlns:a16="http://schemas.microsoft.com/office/drawing/2014/main" id="{7ACEF5B9-9030-4B6F-81BF-E688783A87C5}"/>
+                <a16:creationId xmlns:a16="http://schemas.microsoft.com/office/drawing/2014/main" id="{B83E21BC-49BC-4D8D-9F13-508C232006EA}"/>
               </a:ext>
             </a:extLst>
           </p:cNvPr>
@@ -4923,7 +4923,7 @@
           <p:cNvPr id="3" name="">
             <a:extLst xmlns:a="http://schemas.openxmlformats.org/drawingml/2006/main">
               <a:ext uri="{FF2B5EF4-FFF2-40B4-BE49-F238E27FC236}">
-                <a16:creationId xmlns:a16="http://schemas.microsoft.com/office/drawing/2014/main" id="{58E6DED5-5838-49BC-B1EA-06185CAF9D2B}"/>
+                <a16:creationId xmlns:a16="http://schemas.microsoft.com/office/drawing/2014/main" id="{BF75BAF1-B9F7-48AB-BE10-CB80309DE843}"/>
               </a:ext>
             </a:extLst>
           </p:cNvPr>
@@ -4980,7 +4980,7 @@
           <p:cNvPr id="4" name="">
             <a:extLst xmlns:a="http://schemas.openxmlformats.org/drawingml/2006/main">
               <a:ext uri="{FF2B5EF4-FFF2-40B4-BE49-F238E27FC236}">
-                <a16:creationId xmlns:a16="http://schemas.microsoft.com/office/drawing/2014/main" id="{C90BFA42-1DA3-47A7-81B2-C961C322975B}"/>
+                <a16:creationId xmlns:a16="http://schemas.microsoft.com/office/drawing/2014/main" id="{BEDF8242-0A80-4834-B57E-B75A838C0344}"/>
               </a:ext>
             </a:extLst>
           </p:cNvPr>
@@ -5037,7 +5037,7 @@
           <p:cNvPr id="5" name="">
             <a:extLst xmlns:a="http://schemas.openxmlformats.org/drawingml/2006/main">
               <a:ext uri="{FF2B5EF4-FFF2-40B4-BE49-F238E27FC236}">
-                <a16:creationId xmlns:a16="http://schemas.microsoft.com/office/drawing/2014/main" id="{EEDBDE19-95F9-4A2E-B8EE-FE2DA20AF879}"/>
+                <a16:creationId xmlns:a16="http://schemas.microsoft.com/office/drawing/2014/main" id="{1A7A638A-4FE0-4550-BB67-46D0778F0173}"/>
               </a:ext>
             </a:extLst>
           </p:cNvPr>
@@ -5094,7 +5094,7 @@
           <p:cNvPr id="6" name="">
             <a:extLst xmlns:a="http://schemas.openxmlformats.org/drawingml/2006/main">
               <a:ext uri="{FF2B5EF4-FFF2-40B4-BE49-F238E27FC236}">
-                <a16:creationId xmlns:a16="http://schemas.microsoft.com/office/drawing/2014/main" id="{F7B4CF1A-6281-49B8-851E-D7EE0278DF9D}"/>
+                <a16:creationId xmlns:a16="http://schemas.microsoft.com/office/drawing/2014/main" id="{E66D6842-ADFB-4A80-A0EB-FA77CFB8D9B2}"/>
               </a:ext>
             </a:extLst>
           </p:cNvPr>
@@ -5141,7 +5141,7 @@
                 <a:ea typeface="Helvetica Neue"/>
                 <a:cs typeface="Helvetica Neue"/>
               </a:rPr>
-              <a:t>10 public Firebase browser tests pass across workflow, sign-in, persistence, exports and mobile use.</a:t>
+              <a:t>12 public Firebase browser tests pass across workflow, sign-in, persistence, exports and mobile use.</a:t>
             </a:r>
           </a:p>
         </p:txBody>
@@ -5151,7 +5151,7 @@
           <p:cNvPr id="7" name="">
             <a:extLst xmlns:a="http://schemas.openxmlformats.org/drawingml/2006/main">
               <a:ext uri="{FF2B5EF4-FFF2-40B4-BE49-F238E27FC236}">
-                <a16:creationId xmlns:a16="http://schemas.microsoft.com/office/drawing/2014/main" id="{30AFABA8-34BE-4D8F-8EC1-1DD31F740810}"/>
+                <a16:creationId xmlns:a16="http://schemas.microsoft.com/office/drawing/2014/main" id="{90AEADF5-123C-4089-9D2C-F899B7836DC5}"/>
               </a:ext>
             </a:extLst>
           </p:cNvPr>
@@ -5208,7 +5208,7 @@
           <p:cNvPr id="8" name="">
             <a:extLst xmlns:a="http://schemas.openxmlformats.org/drawingml/2006/main">
               <a:ext uri="{FF2B5EF4-FFF2-40B4-BE49-F238E27FC236}">
-                <a16:creationId xmlns:a16="http://schemas.microsoft.com/office/drawing/2014/main" id="{DD16BE4C-ACE8-452C-A93A-95EF26B6CEA2}"/>
+                <a16:creationId xmlns:a16="http://schemas.microsoft.com/office/drawing/2014/main" id="{5224CA60-D364-4CB7-9F29-D9DBDD36B323}"/>
               </a:ext>
             </a:extLst>
           </p:cNvPr>
@@ -5311,7 +5311,7 @@
           <p:cNvPr id="9" name="">
             <a:extLst xmlns:a="http://schemas.openxmlformats.org/drawingml/2006/main">
               <a:ext uri="{FF2B5EF4-FFF2-40B4-BE49-F238E27FC236}">
-                <a16:creationId xmlns:a16="http://schemas.microsoft.com/office/drawing/2014/main" id="{507E56CD-98B5-418A-BBB7-DADE8C05B5F0}"/>
+                <a16:creationId xmlns:a16="http://schemas.microsoft.com/office/drawing/2014/main" id="{C2802FE6-8EA9-4736-A025-236A8C486BB4}"/>
               </a:ext>
             </a:extLst>
           </p:cNvPr>
@@ -5368,7 +5368,7 @@
           <p:cNvPr id="10" name="">
             <a:extLst xmlns:a="http://schemas.openxmlformats.org/drawingml/2006/main">
               <a:ext uri="{FF2B5EF4-FFF2-40B4-BE49-F238E27FC236}">
-                <a16:creationId xmlns:a16="http://schemas.microsoft.com/office/drawing/2014/main" id="{D55FE8A3-3EE7-4011-9859-EC0603CDC16D}"/>
+                <a16:creationId xmlns:a16="http://schemas.microsoft.com/office/drawing/2014/main" id="{309FC86F-B6AB-4A3B-BF9D-5EBA6EFA3680}"/>
               </a:ext>
             </a:extLst>
           </p:cNvPr>
@@ -5423,7 +5423,7 @@
     </p:spTree>
     <p:extLst>
       <p:ext uri="{BB962C8B-B14F-4D97-AF65-F5344CB8AC3E}">
-        <p14:creationId xmlns:p14="http://schemas.microsoft.com/office/powerpoint/2010/main" val="2146711248"/>
+        <p14:creationId xmlns:p14="http://schemas.microsoft.com/office/powerpoint/2010/main" val="1432590944"/>
       </p:ext>
     </p:extLst>
   </p:cSld>
@@ -5454,7 +5454,7 @@
           <p:cNvPr id="9" name="">
             <a:extLst xmlns:a="http://schemas.openxmlformats.org/drawingml/2006/main">
               <a:ext uri="{FF2B5EF4-FFF2-40B4-BE49-F238E27FC236}">
-                <a16:creationId xmlns:a16="http://schemas.microsoft.com/office/drawing/2014/main" id="{5C965DC1-89A4-435C-9346-214473D950CE}"/>
+                <a16:creationId xmlns:a16="http://schemas.microsoft.com/office/drawing/2014/main" id="{8EAA8975-7BA9-4BDE-B0CD-1BBE597754C2}"/>
               </a:ext>
             </a:extLst>
           </p:cNvPr>
@@ -5511,7 +5511,7 @@
           <p:cNvPr id="2" name="">
             <a:extLst xmlns:a="http://schemas.openxmlformats.org/drawingml/2006/main">
               <a:ext uri="{FF2B5EF4-FFF2-40B4-BE49-F238E27FC236}">
-                <a16:creationId xmlns:a16="http://schemas.microsoft.com/office/drawing/2014/main" id="{4929A45B-F2B7-4D6D-8378-B6873AEF6A49}"/>
+                <a16:creationId xmlns:a16="http://schemas.microsoft.com/office/drawing/2014/main" id="{A13936DC-A065-4D3D-8645-EAC49D9D399D}"/>
               </a:ext>
             </a:extLst>
           </p:cNvPr>
@@ -5568,7 +5568,7 @@
           <p:cNvPr id="3" name="">
             <a:extLst xmlns:a="http://schemas.openxmlformats.org/drawingml/2006/main">
               <a:ext uri="{FF2B5EF4-FFF2-40B4-BE49-F238E27FC236}">
-                <a16:creationId xmlns:a16="http://schemas.microsoft.com/office/drawing/2014/main" id="{4A69E0A6-2288-497E-93C0-6186705555F2}"/>
+                <a16:creationId xmlns:a16="http://schemas.microsoft.com/office/drawing/2014/main" id="{E5B31579-80C5-4A14-84C6-3DF26508C3F4}"/>
               </a:ext>
             </a:extLst>
           </p:cNvPr>
@@ -5648,7 +5648,7 @@
           <p:cNvPr id="4" name="">
             <a:extLst xmlns:a="http://schemas.openxmlformats.org/drawingml/2006/main">
               <a:ext uri="{FF2B5EF4-FFF2-40B4-BE49-F238E27FC236}">
-                <a16:creationId xmlns:a16="http://schemas.microsoft.com/office/drawing/2014/main" id="{9067ECDB-E4B7-4C21-AFF4-31EC93727DDD}"/>
+                <a16:creationId xmlns:a16="http://schemas.microsoft.com/office/drawing/2014/main" id="{FBDE0FE3-3CC3-40F6-8053-EF8EF770F398}"/>
               </a:ext>
             </a:extLst>
           </p:cNvPr>
@@ -5705,7 +5705,7 @@
           <p:cNvPr id="5" name="">
             <a:extLst xmlns:a="http://schemas.openxmlformats.org/drawingml/2006/main">
               <a:ext uri="{FF2B5EF4-FFF2-40B4-BE49-F238E27FC236}">
-                <a16:creationId xmlns:a16="http://schemas.microsoft.com/office/drawing/2014/main" id="{0885D7A0-2241-4773-B0B4-0E8F75B5925C}"/>
+                <a16:creationId xmlns:a16="http://schemas.microsoft.com/office/drawing/2014/main" id="{8AAB97AA-6034-4654-9BCB-27FEF0A8D0CE}"/>
               </a:ext>
             </a:extLst>
           </p:cNvPr>
@@ -5785,7 +5785,7 @@
           <p:cNvPr id="6" name="">
             <a:extLst xmlns:a="http://schemas.openxmlformats.org/drawingml/2006/main">
               <a:ext uri="{FF2B5EF4-FFF2-40B4-BE49-F238E27FC236}">
-                <a16:creationId xmlns:a16="http://schemas.microsoft.com/office/drawing/2014/main" id="{B48CBFF7-D941-4A33-B60A-93AD08415094}"/>
+                <a16:creationId xmlns:a16="http://schemas.microsoft.com/office/drawing/2014/main" id="{858E2C5F-5F0D-4659-8513-BBC37F3109C2}"/>
               </a:ext>
             </a:extLst>
           </p:cNvPr>
@@ -5842,7 +5842,7 @@
           <p:cNvPr id="7" name="">
             <a:extLst xmlns:a="http://schemas.openxmlformats.org/drawingml/2006/main">
               <a:ext uri="{FF2B5EF4-FFF2-40B4-BE49-F238E27FC236}">
-                <a16:creationId xmlns:a16="http://schemas.microsoft.com/office/drawing/2014/main" id="{6C52DB82-C3E5-4AD9-BC36-1C6536DF332E}"/>
+                <a16:creationId xmlns:a16="http://schemas.microsoft.com/office/drawing/2014/main" id="{396ABAAE-DCF3-4F35-8F67-9AFF01C35B45}"/>
               </a:ext>
             </a:extLst>
           </p:cNvPr>
@@ -5899,7 +5899,7 @@
           <p:cNvPr id="8" name="">
             <a:extLst xmlns:a="http://schemas.openxmlformats.org/drawingml/2006/main">
               <a:ext uri="{FF2B5EF4-FFF2-40B4-BE49-F238E27FC236}">
-                <a16:creationId xmlns:a16="http://schemas.microsoft.com/office/drawing/2014/main" id="{3B6B0722-788B-46A4-9DF1-55616E2B0C6D}"/>
+                <a16:creationId xmlns:a16="http://schemas.microsoft.com/office/drawing/2014/main" id="{CF83E21E-2703-498C-AFDB-D403F0F43779}"/>
               </a:ext>
             </a:extLst>
           </p:cNvPr>
@@ -5977,7 +5977,7 @@
     </p:spTree>
     <p:extLst>
       <p:ext uri="{BB962C8B-B14F-4D97-AF65-F5344CB8AC3E}">
-        <p14:creationId xmlns:p14="http://schemas.microsoft.com/office/powerpoint/2010/main" val="222805706"/>
+        <p14:creationId xmlns:p14="http://schemas.microsoft.com/office/powerpoint/2010/main" val="188268254"/>
       </p:ext>
     </p:extLst>
   </p:cSld>

</xml_diff>